<commit_message>
Recompute entire analysis for IM window (2023→2025)
Replace pre/post-COVID averaging with strict 2023→2025 endpoint
deltas across all charts, slides, and PPTX. Key changes:
- Troy IM-window recovery: +0.076, rank 13/22 districts, 6th/8 MI peers
- G6 Asian now strongest recovery (+0.312), slide 11 reframed
- G7 Asian only subgroup still declining (−0.028)
- Charts 03/07/09/10/12 recomputed; slides 2/5-13/17/20/21 rewritten

Co-Authored-By: Claude Opus 4.6 <noreply@anthropic.com>
</commit_message>
<xml_diff>
--- a/deck/Troy_G6G7_Math_Executive_Summary.pptx
+++ b/deck/Troy_G6G7_Math_Executive_Summary.pptx
@@ -3634,7 +3634,7 @@
               </a:defRPr>
             </a:pPr>
             <a:r>
-              <a:t>2023-24: G7 tracked. 2024-25: First G7 IM cohort — recovery stalled</a:t>
+              <a:t>2023-24 G7 tracked (+0.018). 2024-25 first G7 IM cohort (+0.061)</a:t>
             </a:r>
           </a:p>
         </p:txBody>
@@ -3888,7 +3888,7 @@
               </a:defRPr>
             </a:pPr>
             <a:r>
-              <a:t>Troy matched peers when G7 still used the tracked curriculum with Big Ideas Math and honors pathways.</a:t>
+              <a:t>G7 still used Big Ideas Math with tracking. Troy gained +0.018 — 7th of 8 MI peers.</a:t>
             </a:r>
           </a:p>
         </p:txBody>
@@ -3908,7 +3908,7 @@
             <a:avLst/>
           </a:prstGeom>
           <a:solidFill>
-            <a:srgbClr val="FBE7E6"/>
+            <a:srgbClr val="E8F5EE"/>
           </a:solidFill>
           <a:ln>
             <a:noFill/>
@@ -3961,7 +3961,7 @@
             <a:pPr algn="l">
               <a:defRPr sz="1400" b="1">
                 <a:solidFill>
-                  <a:srgbClr val="C8302F"/>
+                  <a:srgbClr val="1F7A3D"/>
                 </a:solidFill>
                 <a:latin typeface="Calibri"/>
               </a:defRPr>
@@ -4003,7 +4003,7 @@
               </a:defRPr>
             </a:pPr>
             <a:r>
-              <a:t>Recovery stalled. The first cohort to experience IM in both G6 and G7 shows no additional gains over the prior tracked year.</a:t>
+              <a:t>Troy gained +0.061 — 2nd of 8 MI peers. Recovery accelerated under IM.</a:t>
             </a:r>
           </a:p>
         </p:txBody>
@@ -4108,7 +4108,7 @@
               </a:defRPr>
             </a:pPr>
             <a:r>
-              <a:t>The Asian Subgroup Crisis — 36% of Troy’s Enrollment</a:t>
+              <a:t>Asian Subgroup: G6 Leads Recovery, G7 Lags</a:t>
             </a:r>
           </a:p>
         </p:txBody>
@@ -4144,7 +4144,7 @@
               </a:defRPr>
             </a:pPr>
             <a:r>
-              <a:t>Troy’s historically strongest demographic shows the sharpest decline</a:t>
+              <a:t>36% of Troy — strongest G6 IM-window recovery of any subgroup</a:t>
             </a:r>
           </a:p>
         </p:txBody>
@@ -4303,7 +4303,7 @@
             <a:avLst/>
           </a:prstGeom>
           <a:solidFill>
-            <a:srgbClr val="FBE7E6"/>
+            <a:srgbClr val="F2F4F7"/>
           </a:solidFill>
           <a:ln>
             <a:noFill/>
@@ -4362,7 +4362,7 @@
               </a:defRPr>
             </a:pPr>
             <a:r>
-              <a:t>G6 Asian Δ COVID:</a:t>
+              <a:t>G6 Asian IM Δ:</a:t>
             </a:r>
           </a:p>
         </p:txBody>
@@ -4392,13 +4392,13 @@
             <a:pPr algn="l">
               <a:defRPr sz="3000" b="1">
                 <a:solidFill>
-                  <a:srgbClr val="C8302F"/>
-                </a:solidFill>
-                <a:latin typeface="Calibri"/>
-              </a:defRPr>
-            </a:pPr>
-            <a:r>
-              <a:t>−0.409</a:t>
+                  <a:srgbClr val="1F7A3D"/>
+                </a:solidFill>
+                <a:latin typeface="Calibri"/>
+              </a:defRPr>
+            </a:pPr>
+            <a:r>
+              <a:t>+0.312</a:t>
             </a:r>
           </a:p>
         </p:txBody>
@@ -4406,6 +4406,42 @@
       <p:sp>
         <p:nvSpPr>
           <p:cNvPr id="12" name="TextBox 11"/>
+          <p:cNvSpPr txBox="1"/>
+          <p:nvPr/>
+        </p:nvSpPr>
+        <p:spPr>
+          <a:xfrm>
+            <a:off x="8366760" y="1965960"/>
+            <a:ext cx="3474719" cy="457200"/>
+          </a:xfrm>
+          <a:prstGeom prst="rect">
+            <a:avLst/>
+          </a:prstGeom>
+          <a:noFill/>
+        </p:spPr>
+        <p:txBody>
+          <a:bodyPr wrap="square" anchor="t">
+            <a:spAutoFit/>
+          </a:bodyPr>
+          <a:lstStyle/>
+          <a:p>
+            <a:pPr algn="l">
+              <a:defRPr sz="1100" b="0">
+                <a:solidFill>
+                  <a:srgbClr val="333333"/>
+                </a:solidFill>
+                <a:latin typeface="Calibri"/>
+              </a:defRPr>
+            </a:pPr>
+            <a:r>
+              <a:t>Strongest recovery of any Troy subgroup. #2 among MI peers in G6 Asian.</a:t>
+            </a:r>
+          </a:p>
+        </p:txBody>
+      </p:sp>
+      <p:sp>
+        <p:nvSpPr>
+          <p:cNvPr id="13" name="TextBox 12"/>
           <p:cNvSpPr txBox="1"/>
           <p:nvPr/>
         </p:nvSpPr>
@@ -4434,14 +4470,14 @@
               </a:defRPr>
             </a:pPr>
             <a:r>
-              <a:t>G7 Asian Δ COVID:</a:t>
-            </a:r>
-          </a:p>
-        </p:txBody>
-      </p:sp>
-      <p:sp>
-        <p:nvSpPr>
-          <p:cNvPr id="13" name="TextBox 12"/>
+              <a:t>G7 Asian IM Δ:</a:t>
+            </a:r>
+          </a:p>
+        </p:txBody>
+      </p:sp>
+      <p:sp>
+        <p:nvSpPr>
+          <p:cNvPr id="14" name="TextBox 13"/>
           <p:cNvSpPr txBox="1"/>
           <p:nvPr/>
         </p:nvSpPr>
@@ -4470,14 +4506,50 @@
               </a:defRPr>
             </a:pPr>
             <a:r>
-              <a:t>−0.278</a:t>
-            </a:r>
-          </a:p>
-        </p:txBody>
-      </p:sp>
-      <p:sp>
-        <p:nvSpPr>
-          <p:cNvPr id="14" name="TextBox 13"/>
+              <a:t>−0.028</a:t>
+            </a:r>
+          </a:p>
+        </p:txBody>
+      </p:sp>
+      <p:sp>
+        <p:nvSpPr>
+          <p:cNvPr id="15" name="TextBox 14"/>
+          <p:cNvSpPr txBox="1"/>
+          <p:nvPr/>
+        </p:nvSpPr>
+        <p:spPr>
+          <a:xfrm>
+            <a:off x="8366760" y="3429000"/>
+            <a:ext cx="3474719" cy="457200"/>
+          </a:xfrm>
+          <a:prstGeom prst="rect">
+            <a:avLst/>
+          </a:prstGeom>
+          <a:noFill/>
+        </p:spPr>
+        <p:txBody>
+          <a:bodyPr wrap="square" anchor="t">
+            <a:spAutoFit/>
+          </a:bodyPr>
+          <a:lstStyle/>
+          <a:p>
+            <a:pPr algn="l">
+              <a:defRPr sz="1100" b="0">
+                <a:solidFill>
+                  <a:srgbClr val="333333"/>
+                </a:solidFill>
+                <a:latin typeface="Calibri"/>
+              </a:defRPr>
+            </a:pPr>
+            <a:r>
+              <a:t>Only subgroup still declining. G7 had just one year of IM.</a:t>
+            </a:r>
+          </a:p>
+        </p:txBody>
+      </p:sp>
+      <p:sp>
+        <p:nvSpPr>
+          <p:cNvPr id="16" name="TextBox 15"/>
           <p:cNvSpPr txBox="1"/>
           <p:nvPr/>
         </p:nvSpPr>
@@ -4506,14 +4578,14 @@
               </a:defRPr>
             </a:pPr>
             <a:r>
-              <a:t>G7 Asian IM-window:</a:t>
-            </a:r>
-          </a:p>
-        </p:txBody>
-      </p:sp>
-      <p:sp>
-        <p:nvSpPr>
-          <p:cNvPr id="15" name="TextBox 14"/>
+              <a:t>Gap from pre-COVID:</a:t>
+            </a:r>
+          </a:p>
+        </p:txBody>
+      </p:sp>
+      <p:sp>
+        <p:nvSpPr>
+          <p:cNvPr id="17" name="TextBox 16"/>
           <p:cNvSpPr txBox="1"/>
           <p:nvPr/>
         </p:nvSpPr>
@@ -4536,49 +4608,49 @@
             <a:pPr algn="l">
               <a:defRPr sz="3000" b="1">
                 <a:solidFill>
-                  <a:srgbClr val="C8302F"/>
-                </a:solidFill>
-                <a:latin typeface="Calibri"/>
-              </a:defRPr>
-            </a:pPr>
-            <a:r>
-              <a:t>−0.094</a:t>
-            </a:r>
-          </a:p>
-        </p:txBody>
-      </p:sp>
-      <p:sp>
-        <p:nvSpPr>
-          <p:cNvPr id="16" name="TextBox 15"/>
-          <p:cNvSpPr txBox="1"/>
-          <p:nvPr/>
-        </p:nvSpPr>
-        <p:spPr>
-          <a:xfrm>
-            <a:off x="8366760" y="4937760"/>
-            <a:ext cx="3474719" cy="320040"/>
-          </a:xfrm>
-          <a:prstGeom prst="rect">
-            <a:avLst/>
-          </a:prstGeom>
-          <a:noFill/>
-        </p:spPr>
-        <p:txBody>
-          <a:bodyPr wrap="square" anchor="t">
-            <a:spAutoFit/>
-          </a:bodyPr>
-          <a:lstStyle/>
-          <a:p>
-            <a:pPr algn="l">
-              <a:defRPr sz="1400" b="1">
-                <a:solidFill>
-                  <a:srgbClr val="C8302F"/>
-                </a:solidFill>
-                <a:latin typeface="Calibri"/>
-              </a:defRPr>
-            </a:pPr>
-            <a:r>
-              <a:t>(still declining)</a:t>
+                  <a:srgbClr val="B7791F"/>
+                </a:solidFill>
+                <a:latin typeface="Calibri"/>
+              </a:defRPr>
+            </a:pPr>
+            <a:r>
+              <a:t>−0.340</a:t>
+            </a:r>
+          </a:p>
+        </p:txBody>
+      </p:sp>
+      <p:sp>
+        <p:nvSpPr>
+          <p:cNvPr id="18" name="TextBox 17"/>
+          <p:cNvSpPr txBox="1"/>
+          <p:nvPr/>
+        </p:nvSpPr>
+        <p:spPr>
+          <a:xfrm>
+            <a:off x="8366760" y="4892040"/>
+            <a:ext cx="3474719" cy="457200"/>
+          </a:xfrm>
+          <a:prstGeom prst="rect">
+            <a:avLst/>
+          </a:prstGeom>
+          <a:noFill/>
+        </p:spPr>
+        <p:txBody>
+          <a:bodyPr wrap="square" anchor="t">
+            <a:spAutoFit/>
+          </a:bodyPr>
+          <a:lstStyle/>
+          <a:p>
+            <a:pPr algn="l">
+              <a:defRPr sz="1100" b="0">
+                <a:solidFill>
+                  <a:srgbClr val="333333"/>
+                </a:solidFill>
+                <a:latin typeface="Calibri"/>
+              </a:defRPr>
+            </a:pPr>
+            <a:r>
+              <a:t>G7 Asian still far below 2017-19 baseline despite G6 recovery.</a:t>
             </a:r>
           </a:p>
         </p:txBody>
@@ -4683,7 +4755,7 @@
               </a:defRPr>
             </a:pPr>
             <a:r>
-              <a:t>G7 Asian Math Is Still Declining Under IM</a:t>
+              <a:t>G7 Asian: First IM Year Shows Slight Decline</a:t>
             </a:r>
           </a:p>
         </p:txBody>
@@ -4719,7 +4791,7 @@
               </a:defRPr>
             </a:pPr>
             <a:r>
-              <a:t>High-Asian peers with tracking show robust recovery</a:t>
+              <a:t>High-Asian peers with tracking outpace Troy's G7 Asian (2023 → 2025)</a:t>
             </a:r>
           </a:p>
         </p:txBody>
@@ -4937,7 +5009,7 @@
               </a:defRPr>
             </a:pPr>
             <a:r>
-              <a:t>Bellevue (WA)</a:t>
+              <a:t>Issaquah (WA)</a:t>
             </a:r>
           </a:p>
         </p:txBody>
@@ -4973,7 +5045,7 @@
               </a:defRPr>
             </a:pPr>
             <a:r>
-              <a:t>+0.162</a:t>
+              <a:t>+0.384</a:t>
             </a:r>
           </a:p>
         </p:txBody>
@@ -5052,7 +5124,7 @@
               </a:defRPr>
             </a:pPr>
             <a:r>
-              <a:t>Issaquah (WA)</a:t>
+              <a:t>Bellevue (WA)</a:t>
             </a:r>
           </a:p>
         </p:txBody>
@@ -5088,7 +5160,7 @@
               </a:defRPr>
             </a:pPr>
             <a:r>
-              <a:t>+0.218</a:t>
+              <a:t>+0.192</a:t>
             </a:r>
           </a:p>
         </p:txBody>
@@ -5203,7 +5275,7 @@
               </a:defRPr>
             </a:pPr>
             <a:r>
-              <a:t>−0.094</a:t>
+              <a:t>−0.028</a:t>
             </a:r>
           </a:p>
         </p:txBody>
@@ -5308,7 +5380,7 @@
               </a:defRPr>
             </a:pPr>
             <a:r>
-              <a:t>Every Subgroup Declined — But Recovery Is Uneven</a:t>
+              <a:t>IM-Window Recovery by Subgroup (2023 → 2025)</a:t>
             </a:r>
           </a:p>
         </p:txBody>
@@ -5344,7 +5416,7 @@
               </a:defRPr>
             </a:pPr>
             <a:r>
-              <a:t>Asian and White subgroups show largest absolute declines</a:t>
+              <a:t>Asian leads combined recovery; White lags peers</a:t>
             </a:r>
           </a:p>
         </p:txBody>
@@ -5601,7 +5673,7 @@
               </a:defRPr>
             </a:pPr>
             <a:r>
-              <a:t>Asian and White subgroups show the largest absolute declines from pre-COVID levels.</a:t>
+              <a:t>Every subgroup recovered except G7 Asian (-0.028).</a:t>
             </a:r>
           </a:p>
           <a:p>
@@ -5630,7 +5702,7 @@
               </a:defRPr>
             </a:pPr>
             <a:r>
-              <a:t>Economically disadvantaged students were already near the national average — the gap between ECD and non-ECD has not narrowed.</a:t>
+              <a:t>Asian G6 leads recovery (+0.312), strongest of any Troy subgroup.</a:t>
             </a:r>
           </a:p>
           <a:p>
@@ -5659,7 +5731,7 @@
               </a:defRPr>
             </a:pPr>
             <a:r>
-              <a:t>No subgroup has returned to pre-COVID performance under IM + detracking.</a:t>
+              <a:t>White subgroup barely improved (+0.023 combined), 7th of 8 MI peers in G6.</a:t>
             </a:r>
           </a:p>
           <a:p>
@@ -5688,7 +5760,36 @@
               </a:defRPr>
             </a:pPr>
             <a:r>
-              <a:t>The “rising tide lifts all boats” promise of detracking has not materialised for any demographic group in Troy.</a:t>
+              <a:t>ECD recovery is mixed: G6 flat (-0.007), G7 strong (+0.149, 3rd of 8).</a:t>
+            </a:r>
+          </a:p>
+          <a:p>
+            <a:pPr algn="l">
+              <a:spcAft>
+                <a:spcPts val="400"/>
+              </a:spcAft>
+              <a:defRPr sz="1400" b="0">
+                <a:solidFill>
+                  <a:srgbClr val="333333"/>
+                </a:solidFill>
+                <a:latin typeface="Calibri"/>
+              </a:defRPr>
+            </a:pPr>
+          </a:p>
+          <a:p>
+            <a:pPr algn="l">
+              <a:spcAft>
+                <a:spcPts val="400"/>
+              </a:spcAft>
+              <a:defRPr sz="1400" b="0">
+                <a:solidFill>
+                  <a:srgbClr val="333333"/>
+                </a:solidFill>
+                <a:latin typeface="Calibri"/>
+              </a:defRPr>
+            </a:pPr>
+            <a:r>
+              <a:t>All subgroups remain below pre-COVID levels.</a:t>
             </a:r>
           </a:p>
         </p:txBody>
@@ -9128,7 +9229,7 @@
               </a:defRPr>
             </a:pPr>
             <a:r>
-              <a:t>SEDA shows Troy’s G6+G7 math readiness dropped from +0.937 to +0.750 — a quarter-grade-level decline</a:t>
+              <a:t>SEDA shows Troy rose +0.076 in the IM window (2023→2025) but remains far below pre-COVID +0.937</a:t>
             </a:r>
           </a:p>
         </p:txBody>
@@ -11598,7 +11699,7 @@
               </a:defRPr>
             </a:pPr>
             <a:r>
-              <a:t>59 positions</a:t>
+              <a:t>6th of 8</a:t>
             </a:r>
           </a:p>
         </p:txBody>
@@ -11634,7 +11735,7 @@
               </a:defRPr>
             </a:pPr>
             <a:r>
-              <a:t>Lost in national rankings — from #76 (top quarter) to #135 (mid-pack)</a:t>
+              <a:t>MI peers outpaced Troy in IM-window recovery (+0.076 vs +0.080 median)</a:t>
             </a:r>
           </a:p>
         </p:txBody>
@@ -11654,7 +11755,7 @@
             <a:avLst/>
           </a:prstGeom>
           <a:solidFill>
-            <a:srgbClr val="E8F5EE"/>
+            <a:srgbClr val="FBE7E6"/>
           </a:solidFill>
           <a:ln>
             <a:noFill/>
@@ -11697,7 +11798,7 @@
             <a:avLst/>
           </a:prstGeom>
           <a:solidFill>
-            <a:srgbClr val="1F7A3D"/>
+            <a:srgbClr val="C8302F"/>
           </a:solidFill>
           <a:ln>
             <a:noFill/>
@@ -11750,13 +11851,13 @@
             <a:pPr algn="l">
               <a:defRPr sz="3000" b="1">
                 <a:solidFill>
-                  <a:srgbClr val="1F7A3D"/>
-                </a:solidFill>
-                <a:latin typeface="Calibri"/>
-              </a:defRPr>
-            </a:pPr>
-            <a:r>
-              <a:t>9×</a:t>
+                  <a:srgbClr val="C8302F"/>
+                </a:solidFill>
+                <a:latin typeface="Calibri"/>
+              </a:defRPr>
+            </a:pPr>
+            <a:r>
+              <a:t>−0.028</a:t>
             </a:r>
           </a:p>
         </p:txBody>
@@ -11792,7 +11893,7 @@
               </a:defRPr>
             </a:pPr>
             <a:r>
-              <a:t>Birmingham recovered 9× more than Troy in the same window, same county, with tracking intact</a:t>
+              <a:t>G7 Asian still declining under IM — only subgroup not recovering</a:t>
             </a:r>
           </a:p>
         </p:txBody>
@@ -12068,6 +12169,207 @@
             <a:avLst/>
           </a:prstGeom>
           <a:solidFill>
+            <a:srgbClr val="FFF4E0"/>
+          </a:solidFill>
+          <a:ln>
+            <a:noFill/>
+          </a:ln>
+        </p:spPr>
+        <p:style>
+          <a:lnRef idx="1">
+            <a:schemeClr val="accent1"/>
+          </a:lnRef>
+          <a:fillRef idx="3">
+            <a:schemeClr val="accent1"/>
+          </a:fillRef>
+          <a:effectRef idx="2">
+            <a:schemeClr val="accent1"/>
+          </a:effectRef>
+          <a:fontRef idx="minor">
+            <a:schemeClr val="lt1"/>
+          </a:fontRef>
+        </p:style>
+        <p:txBody>
+          <a:bodyPr rtlCol="0" anchor="ctr"/>
+          <a:lstStyle/>
+          <a:p>
+            <a:pPr algn="ctr"/>
+          </a:p>
+        </p:txBody>
+      </p:sp>
+      <p:sp>
+        <p:nvSpPr>
+          <p:cNvPr id="9" name="Rectangle 8"/>
+          <p:cNvSpPr/>
+          <p:nvPr/>
+        </p:nvSpPr>
+        <p:spPr>
+          <a:xfrm>
+            <a:off x="640080" y="1252728"/>
+            <a:ext cx="457200" cy="457200"/>
+          </a:xfrm>
+          <a:prstGeom prst="rect">
+            <a:avLst/>
+          </a:prstGeom>
+          <a:solidFill>
+            <a:srgbClr val="B7791F"/>
+          </a:solidFill>
+          <a:ln>
+            <a:noFill/>
+          </a:ln>
+        </p:spPr>
+        <p:style>
+          <a:lnRef idx="1">
+            <a:schemeClr val="accent1"/>
+          </a:lnRef>
+          <a:fillRef idx="3">
+            <a:schemeClr val="accent1"/>
+          </a:fillRef>
+          <a:effectRef idx="2">
+            <a:schemeClr val="accent1"/>
+          </a:effectRef>
+          <a:fontRef idx="minor">
+            <a:schemeClr val="lt1"/>
+          </a:fontRef>
+        </p:style>
+        <p:txBody>
+          <a:bodyPr rtlCol="0" anchor="ctr"/>
+          <a:lstStyle/>
+          <a:p>
+            <a:pPr algn="ctr"/>
+          </a:p>
+        </p:txBody>
+      </p:sp>
+      <p:sp>
+        <p:nvSpPr>
+          <p:cNvPr id="10" name="TextBox 9"/>
+          <p:cNvSpPr txBox="1"/>
+          <p:nvPr/>
+        </p:nvSpPr>
+        <p:spPr>
+          <a:xfrm>
+            <a:off x="640080" y="1252728"/>
+            <a:ext cx="457200" cy="457200"/>
+          </a:xfrm>
+          <a:prstGeom prst="rect">
+            <a:avLst/>
+          </a:prstGeom>
+          <a:noFill/>
+        </p:spPr>
+        <p:txBody>
+          <a:bodyPr wrap="square" anchor="ctr">
+            <a:spAutoFit/>
+          </a:bodyPr>
+          <a:lstStyle/>
+          <a:p>
+            <a:pPr algn="ctr">
+              <a:defRPr sz="1800" b="1">
+                <a:solidFill>
+                  <a:srgbClr val="FFFFFF"/>
+                </a:solidFill>
+                <a:latin typeface="Calibri"/>
+              </a:defRPr>
+            </a:pPr>
+            <a:r>
+              <a:t>1</a:t>
+            </a:r>
+          </a:p>
+        </p:txBody>
+      </p:sp>
+      <p:sp>
+        <p:nvSpPr>
+          <p:cNvPr id="11" name="Rectangle 10"/>
+          <p:cNvSpPr/>
+          <p:nvPr/>
+        </p:nvSpPr>
+        <p:spPr>
+          <a:xfrm>
+            <a:off x="457200" y="1051560"/>
+            <a:ext cx="54864" cy="960120"/>
+          </a:xfrm>
+          <a:prstGeom prst="rect">
+            <a:avLst/>
+          </a:prstGeom>
+          <a:solidFill>
+            <a:srgbClr val="B7791F"/>
+          </a:solidFill>
+          <a:ln>
+            <a:noFill/>
+          </a:ln>
+        </p:spPr>
+        <p:style>
+          <a:lnRef idx="1">
+            <a:schemeClr val="accent1"/>
+          </a:lnRef>
+          <a:fillRef idx="3">
+            <a:schemeClr val="accent1"/>
+          </a:fillRef>
+          <a:effectRef idx="2">
+            <a:schemeClr val="accent1"/>
+          </a:effectRef>
+          <a:fontRef idx="minor">
+            <a:schemeClr val="lt1"/>
+          </a:fontRef>
+        </p:style>
+        <p:txBody>
+          <a:bodyPr rtlCol="0" anchor="ctr"/>
+          <a:lstStyle/>
+          <a:p>
+            <a:pPr algn="ctr"/>
+          </a:p>
+        </p:txBody>
+      </p:sp>
+      <p:sp>
+        <p:nvSpPr>
+          <p:cNvPr id="12" name="TextBox 11"/>
+          <p:cNvSpPr txBox="1"/>
+          <p:nvPr/>
+        </p:nvSpPr>
+        <p:spPr>
+          <a:xfrm>
+            <a:off x="1280160" y="1143000"/>
+            <a:ext cx="10241280" cy="777240"/>
+          </a:xfrm>
+          <a:prstGeom prst="rect">
+            <a:avLst/>
+          </a:prstGeom>
+          <a:noFill/>
+        </p:spPr>
+        <p:txBody>
+          <a:bodyPr wrap="square" anchor="ctr">
+            <a:spAutoFit/>
+          </a:bodyPr>
+          <a:lstStyle/>
+          <a:p>
+            <a:pPr algn="l">
+              <a:defRPr sz="1600" b="0">
+                <a:solidFill>
+                  <a:srgbClr val="333333"/>
+                </a:solidFill>
+                <a:latin typeface="Calibri"/>
+              </a:defRPr>
+            </a:pPr>
+            <a:r>
+              <a:t>Troy has NOT outperformed — 6th of 8 MI peers, 197/295 nationally</a:t>
+            </a:r>
+          </a:p>
+        </p:txBody>
+      </p:sp>
+      <p:sp>
+        <p:nvSpPr>
+          <p:cNvPr id="13" name="Rectangle 12"/>
+          <p:cNvSpPr/>
+          <p:nvPr/>
+        </p:nvSpPr>
+        <p:spPr>
+          <a:xfrm>
+            <a:off x="457200" y="2121408"/>
+            <a:ext cx="11247120" cy="960120"/>
+          </a:xfrm>
+          <a:prstGeom prst="rect">
+            <a:avLst/>
+          </a:prstGeom>
+          <a:solidFill>
             <a:srgbClr val="FBE7E6"/>
           </a:solidFill>
           <a:ln>
@@ -12098,13 +12400,13 @@
       </p:sp>
       <p:sp>
         <p:nvSpPr>
-          <p:cNvPr id="9" name="Rectangle 8"/>
+          <p:cNvPr id="14" name="Rectangle 13"/>
           <p:cNvSpPr/>
           <p:nvPr/>
         </p:nvSpPr>
         <p:spPr>
           <a:xfrm>
-            <a:off x="640080" y="1252728"/>
+            <a:off x="640080" y="2322576"/>
             <a:ext cx="457200" cy="457200"/>
           </a:xfrm>
           <a:prstGeom prst="rect">
@@ -12141,13 +12443,13 @@
       </p:sp>
       <p:sp>
         <p:nvSpPr>
-          <p:cNvPr id="10" name="TextBox 9"/>
-          <p:cNvSpPr txBox="1"/>
-          <p:nvPr/>
-        </p:nvSpPr>
-        <p:spPr>
-          <a:xfrm>
-            <a:off x="640080" y="1252728"/>
+          <p:cNvPr id="15" name="TextBox 14"/>
+          <p:cNvSpPr txBox="1"/>
+          <p:nvPr/>
+        </p:nvSpPr>
+        <p:spPr>
+          <a:xfrm>
+            <a:off x="640080" y="2322576"/>
             <a:ext cx="457200" cy="457200"/>
           </a:xfrm>
           <a:prstGeom prst="rect">
@@ -12170,20 +12472,20 @@
               </a:defRPr>
             </a:pPr>
             <a:r>
-              <a:t>1</a:t>
-            </a:r>
-          </a:p>
-        </p:txBody>
-      </p:sp>
-      <p:sp>
-        <p:nvSpPr>
-          <p:cNvPr id="11" name="Rectangle 10"/>
+              <a:t>2</a:t>
+            </a:r>
+          </a:p>
+        </p:txBody>
+      </p:sp>
+      <p:sp>
+        <p:nvSpPr>
+          <p:cNvPr id="16" name="Rectangle 15"/>
           <p:cNvSpPr/>
           <p:nvPr/>
         </p:nvSpPr>
         <p:spPr>
           <a:xfrm>
-            <a:off x="457200" y="1051560"/>
+            <a:off x="457200" y="2121408"/>
             <a:ext cx="54864" cy="960120"/>
           </a:xfrm>
           <a:prstGeom prst="rect">
@@ -12220,13 +12522,13 @@
       </p:sp>
       <p:sp>
         <p:nvSpPr>
-          <p:cNvPr id="12" name="TextBox 11"/>
-          <p:cNvSpPr txBox="1"/>
-          <p:nvPr/>
-        </p:nvSpPr>
-        <p:spPr>
-          <a:xfrm>
-            <a:off x="1280160" y="1143000"/>
+          <p:cNvPr id="17" name="TextBox 16"/>
+          <p:cNvSpPr txBox="1"/>
+          <p:nvPr/>
+        </p:nvSpPr>
+        <p:spPr>
+          <a:xfrm>
+            <a:off x="1280160" y="2212848"/>
             <a:ext cx="10241280" cy="777240"/>
           </a:xfrm>
           <a:prstGeom prst="rect">
@@ -12249,27 +12551,27 @@
               </a:defRPr>
             </a:pPr>
             <a:r>
-              <a:t>Troy has NOT outperformed — bottom third of 295 peers</a:t>
-            </a:r>
-          </a:p>
-        </p:txBody>
-      </p:sp>
-      <p:sp>
-        <p:nvSpPr>
-          <p:cNvPr id="13" name="Rectangle 12"/>
+              <a:t>G7 Asian most concerning — only subgroup still declining (−0.028)</a:t>
+            </a:r>
+          </a:p>
+        </p:txBody>
+      </p:sp>
+      <p:sp>
+        <p:nvSpPr>
+          <p:cNvPr id="18" name="Rectangle 17"/>
           <p:cNvSpPr/>
           <p:nvPr/>
         </p:nvSpPr>
         <p:spPr>
           <a:xfrm>
-            <a:off x="457200" y="2121408"/>
+            <a:off x="457200" y="3191256"/>
             <a:ext cx="11247120" cy="960120"/>
           </a:xfrm>
           <a:prstGeom prst="rect">
             <a:avLst/>
           </a:prstGeom>
           <a:solidFill>
-            <a:srgbClr val="FBE7E6"/>
+            <a:srgbClr val="E8F5EE"/>
           </a:solidFill>
           <a:ln>
             <a:noFill/>
@@ -12299,20 +12601,20 @@
       </p:sp>
       <p:sp>
         <p:nvSpPr>
-          <p:cNvPr id="14" name="Rectangle 13"/>
+          <p:cNvPr id="19" name="Rectangle 18"/>
           <p:cNvSpPr/>
           <p:nvPr/>
         </p:nvSpPr>
         <p:spPr>
           <a:xfrm>
-            <a:off x="640080" y="2322576"/>
+            <a:off x="640080" y="3392424"/>
             <a:ext cx="457200" cy="457200"/>
           </a:xfrm>
           <a:prstGeom prst="rect">
             <a:avLst/>
           </a:prstGeom>
           <a:solidFill>
-            <a:srgbClr val="C8302F"/>
+            <a:srgbClr val="1F7A3D"/>
           </a:solidFill>
           <a:ln>
             <a:noFill/>
@@ -12342,13 +12644,13 @@
       </p:sp>
       <p:sp>
         <p:nvSpPr>
-          <p:cNvPr id="15" name="TextBox 14"/>
-          <p:cNvSpPr txBox="1"/>
-          <p:nvPr/>
-        </p:nvSpPr>
-        <p:spPr>
-          <a:xfrm>
-            <a:off x="640080" y="2322576"/>
+          <p:cNvPr id="20" name="TextBox 19"/>
+          <p:cNvSpPr txBox="1"/>
+          <p:nvPr/>
+        </p:nvSpPr>
+        <p:spPr>
+          <a:xfrm>
+            <a:off x="640080" y="3392424"/>
             <a:ext cx="457200" cy="457200"/>
           </a:xfrm>
           <a:prstGeom prst="rect">
@@ -12371,27 +12673,27 @@
               </a:defRPr>
             </a:pPr>
             <a:r>
-              <a:t>2</a:t>
-            </a:r>
-          </a:p>
-        </p:txBody>
-      </p:sp>
-      <p:sp>
-        <p:nvSpPr>
-          <p:cNvPr id="16" name="Rectangle 15"/>
+              <a:t>3</a:t>
+            </a:r>
+          </a:p>
+        </p:txBody>
+      </p:sp>
+      <p:sp>
+        <p:nvSpPr>
+          <p:cNvPr id="21" name="Rectangle 20"/>
           <p:cNvSpPr/>
           <p:nvPr/>
         </p:nvSpPr>
         <p:spPr>
           <a:xfrm>
-            <a:off x="457200" y="2121408"/>
+            <a:off x="457200" y="3191256"/>
             <a:ext cx="54864" cy="960120"/>
           </a:xfrm>
           <a:prstGeom prst="rect">
             <a:avLst/>
           </a:prstGeom>
           <a:solidFill>
-            <a:srgbClr val="C8302F"/>
+            <a:srgbClr val="1F7A3D"/>
           </a:solidFill>
           <a:ln>
             <a:noFill/>
@@ -12421,13 +12723,13 @@
       </p:sp>
       <p:sp>
         <p:nvSpPr>
-          <p:cNvPr id="17" name="TextBox 16"/>
-          <p:cNvSpPr txBox="1"/>
-          <p:nvPr/>
-        </p:nvSpPr>
-        <p:spPr>
-          <a:xfrm>
-            <a:off x="1280160" y="2212848"/>
+          <p:cNvPr id="22" name="TextBox 21"/>
+          <p:cNvSpPr txBox="1"/>
+          <p:nvPr/>
+        </p:nvSpPr>
+        <p:spPr>
+          <a:xfrm>
+            <a:off x="1280160" y="3282696"/>
             <a:ext cx="10241280" cy="777240"/>
           </a:xfrm>
           <a:prstGeom prst="rect">
@@ -12450,20 +12752,20 @@
               </a:defRPr>
             </a:pPr>
             <a:r>
-              <a:t>Asian subgroup most concerning — G7 Asian STILL declining</a:t>
-            </a:r>
-          </a:p>
-        </p:txBody>
-      </p:sp>
-      <p:sp>
-        <p:nvSpPr>
-          <p:cNvPr id="18" name="Rectangle 17"/>
+              <a:t>G6 Asian a bright spot — strongest recovery (+0.312), #2 MI peers</a:t>
+            </a:r>
+          </a:p>
+        </p:txBody>
+      </p:sp>
+      <p:sp>
+        <p:nvSpPr>
+          <p:cNvPr id="23" name="Rectangle 22"/>
           <p:cNvSpPr/>
           <p:nvPr/>
         </p:nvSpPr>
         <p:spPr>
           <a:xfrm>
-            <a:off x="457200" y="3191256"/>
+            <a:off x="457200" y="4261104"/>
             <a:ext cx="11247120" cy="960120"/>
           </a:xfrm>
           <a:prstGeom prst="rect">
@@ -12500,13 +12802,13 @@
       </p:sp>
       <p:sp>
         <p:nvSpPr>
-          <p:cNvPr id="19" name="Rectangle 18"/>
+          <p:cNvPr id="24" name="Rectangle 23"/>
           <p:cNvSpPr/>
           <p:nvPr/>
         </p:nvSpPr>
         <p:spPr>
           <a:xfrm>
-            <a:off x="640080" y="3392424"/>
+            <a:off x="640080" y="4462272"/>
             <a:ext cx="457200" cy="457200"/>
           </a:xfrm>
           <a:prstGeom prst="rect">
@@ -12543,13 +12845,13 @@
       </p:sp>
       <p:sp>
         <p:nvSpPr>
-          <p:cNvPr id="20" name="TextBox 19"/>
-          <p:cNvSpPr txBox="1"/>
-          <p:nvPr/>
-        </p:nvSpPr>
-        <p:spPr>
-          <a:xfrm>
-            <a:off x="640080" y="3392424"/>
+          <p:cNvPr id="25" name="TextBox 24"/>
+          <p:cNvSpPr txBox="1"/>
+          <p:nvPr/>
+        </p:nvSpPr>
+        <p:spPr>
+          <a:xfrm>
+            <a:off x="640080" y="4462272"/>
             <a:ext cx="457200" cy="457200"/>
           </a:xfrm>
           <a:prstGeom prst="rect">
@@ -12572,20 +12874,20 @@
               </a:defRPr>
             </a:pPr>
             <a:r>
-              <a:t>3</a:t>
-            </a:r>
-          </a:p>
-        </p:txBody>
-      </p:sp>
-      <p:sp>
-        <p:nvSpPr>
-          <p:cNvPr id="21" name="Rectangle 20"/>
+              <a:t>4</a:t>
+            </a:r>
+          </a:p>
+        </p:txBody>
+      </p:sp>
+      <p:sp>
+        <p:nvSpPr>
+          <p:cNvPr id="26" name="Rectangle 25"/>
           <p:cNvSpPr/>
           <p:nvPr/>
         </p:nvSpPr>
         <p:spPr>
           <a:xfrm>
-            <a:off x="457200" y="3191256"/>
+            <a:off x="457200" y="4261104"/>
             <a:ext cx="54864" cy="960120"/>
           </a:xfrm>
           <a:prstGeom prst="rect">
@@ -12622,13 +12924,13 @@
       </p:sp>
       <p:sp>
         <p:nvSpPr>
-          <p:cNvPr id="22" name="TextBox 21"/>
-          <p:cNvSpPr txBox="1"/>
-          <p:nvPr/>
-        </p:nvSpPr>
-        <p:spPr>
-          <a:xfrm>
-            <a:off x="1280160" y="3282696"/>
+          <p:cNvPr id="27" name="TextBox 26"/>
+          <p:cNvSpPr txBox="1"/>
+          <p:nvPr/>
+        </p:nvSpPr>
+        <p:spPr>
+          <a:xfrm>
+            <a:off x="1280160" y="4352544"/>
             <a:ext cx="10241280" cy="777240"/>
           </a:xfrm>
           <a:prstGeom prst="rect">
@@ -12658,13 +12960,13 @@
       </p:sp>
       <p:sp>
         <p:nvSpPr>
-          <p:cNvPr id="23" name="Rectangle 22"/>
+          <p:cNvPr id="28" name="Rectangle 27"/>
           <p:cNvSpPr/>
           <p:nvPr/>
         </p:nvSpPr>
         <p:spPr>
           <a:xfrm>
-            <a:off x="457200" y="4261104"/>
+            <a:off x="457200" y="5330952"/>
             <a:ext cx="11247120" cy="960120"/>
           </a:xfrm>
           <a:prstGeom prst="rect">
@@ -12701,13 +13003,13 @@
       </p:sp>
       <p:sp>
         <p:nvSpPr>
-          <p:cNvPr id="24" name="Rectangle 23"/>
+          <p:cNvPr id="29" name="Rectangle 28"/>
           <p:cNvSpPr/>
           <p:nvPr/>
         </p:nvSpPr>
         <p:spPr>
           <a:xfrm>
-            <a:off x="640080" y="4462272"/>
+            <a:off x="640080" y="5532120"/>
             <a:ext cx="457200" cy="457200"/>
           </a:xfrm>
           <a:prstGeom prst="rect">
@@ -12744,13 +13046,13 @@
       </p:sp>
       <p:sp>
         <p:nvSpPr>
-          <p:cNvPr id="25" name="TextBox 24"/>
-          <p:cNvSpPr txBox="1"/>
-          <p:nvPr/>
-        </p:nvSpPr>
-        <p:spPr>
-          <a:xfrm>
-            <a:off x="640080" y="4462272"/>
+          <p:cNvPr id="30" name="TextBox 29"/>
+          <p:cNvSpPr txBox="1"/>
+          <p:nvPr/>
+        </p:nvSpPr>
+        <p:spPr>
+          <a:xfrm>
+            <a:off x="640080" y="5532120"/>
             <a:ext cx="457200" cy="457200"/>
           </a:xfrm>
           <a:prstGeom prst="rect">
@@ -12773,20 +13075,20 @@
               </a:defRPr>
             </a:pPr>
             <a:r>
-              <a:t>4</a:t>
-            </a:r>
-          </a:p>
-        </p:txBody>
-      </p:sp>
-      <p:sp>
-        <p:nvSpPr>
-          <p:cNvPr id="26" name="Rectangle 25"/>
+              <a:t>5</a:t>
+            </a:r>
+          </a:p>
+        </p:txBody>
+      </p:sp>
+      <p:sp>
+        <p:nvSpPr>
+          <p:cNvPr id="31" name="Rectangle 30"/>
           <p:cNvSpPr/>
           <p:nvPr/>
         </p:nvSpPr>
         <p:spPr>
           <a:xfrm>
-            <a:off x="457200" y="4261104"/>
+            <a:off x="457200" y="5330952"/>
             <a:ext cx="54864" cy="960120"/>
           </a:xfrm>
           <a:prstGeom prst="rect">
@@ -12823,207 +13125,6 @@
       </p:sp>
       <p:sp>
         <p:nvSpPr>
-          <p:cNvPr id="27" name="TextBox 26"/>
-          <p:cNvSpPr txBox="1"/>
-          <p:nvPr/>
-        </p:nvSpPr>
-        <p:spPr>
-          <a:xfrm>
-            <a:off x="1280160" y="4352544"/>
-            <a:ext cx="10241280" cy="777240"/>
-          </a:xfrm>
-          <a:prstGeom prst="rect">
-            <a:avLst/>
-          </a:prstGeom>
-          <a:noFill/>
-        </p:spPr>
-        <p:txBody>
-          <a:bodyPr wrap="square" anchor="ctr">
-            <a:spAutoFit/>
-          </a:bodyPr>
-          <a:lstStyle/>
-          <a:p>
-            <a:pPr algn="l">
-              <a:defRPr sz="1600" b="0">
-                <a:solidFill>
-                  <a:srgbClr val="333333"/>
-                </a:solidFill>
-                <a:latin typeface="Calibri"/>
-              </a:defRPr>
-            </a:pPr>
-            <a:r>
-              <a:t>Course enrollment ≠ achievement — 50% Algebra 1 misleads</a:t>
-            </a:r>
-          </a:p>
-        </p:txBody>
-      </p:sp>
-      <p:sp>
-        <p:nvSpPr>
-          <p:cNvPr id="28" name="Rectangle 27"/>
-          <p:cNvSpPr/>
-          <p:nvPr/>
-        </p:nvSpPr>
-        <p:spPr>
-          <a:xfrm>
-            <a:off x="457200" y="5330952"/>
-            <a:ext cx="11247120" cy="960120"/>
-          </a:xfrm>
-          <a:prstGeom prst="rect">
-            <a:avLst/>
-          </a:prstGeom>
-          <a:solidFill>
-            <a:srgbClr val="FBE7E6"/>
-          </a:solidFill>
-          <a:ln>
-            <a:noFill/>
-          </a:ln>
-        </p:spPr>
-        <p:style>
-          <a:lnRef idx="1">
-            <a:schemeClr val="accent1"/>
-          </a:lnRef>
-          <a:fillRef idx="3">
-            <a:schemeClr val="accent1"/>
-          </a:fillRef>
-          <a:effectRef idx="2">
-            <a:schemeClr val="accent1"/>
-          </a:effectRef>
-          <a:fontRef idx="minor">
-            <a:schemeClr val="lt1"/>
-          </a:fontRef>
-        </p:style>
-        <p:txBody>
-          <a:bodyPr rtlCol="0" anchor="ctr"/>
-          <a:lstStyle/>
-          <a:p>
-            <a:pPr algn="ctr"/>
-          </a:p>
-        </p:txBody>
-      </p:sp>
-      <p:sp>
-        <p:nvSpPr>
-          <p:cNvPr id="29" name="Rectangle 28"/>
-          <p:cNvSpPr/>
-          <p:nvPr/>
-        </p:nvSpPr>
-        <p:spPr>
-          <a:xfrm>
-            <a:off x="640080" y="5532120"/>
-            <a:ext cx="457200" cy="457200"/>
-          </a:xfrm>
-          <a:prstGeom prst="rect">
-            <a:avLst/>
-          </a:prstGeom>
-          <a:solidFill>
-            <a:srgbClr val="C8302F"/>
-          </a:solidFill>
-          <a:ln>
-            <a:noFill/>
-          </a:ln>
-        </p:spPr>
-        <p:style>
-          <a:lnRef idx="1">
-            <a:schemeClr val="accent1"/>
-          </a:lnRef>
-          <a:fillRef idx="3">
-            <a:schemeClr val="accent1"/>
-          </a:fillRef>
-          <a:effectRef idx="2">
-            <a:schemeClr val="accent1"/>
-          </a:effectRef>
-          <a:fontRef idx="minor">
-            <a:schemeClr val="lt1"/>
-          </a:fontRef>
-        </p:style>
-        <p:txBody>
-          <a:bodyPr rtlCol="0" anchor="ctr"/>
-          <a:lstStyle/>
-          <a:p>
-            <a:pPr algn="ctr"/>
-          </a:p>
-        </p:txBody>
-      </p:sp>
-      <p:sp>
-        <p:nvSpPr>
-          <p:cNvPr id="30" name="TextBox 29"/>
-          <p:cNvSpPr txBox="1"/>
-          <p:nvPr/>
-        </p:nvSpPr>
-        <p:spPr>
-          <a:xfrm>
-            <a:off x="640080" y="5532120"/>
-            <a:ext cx="457200" cy="457200"/>
-          </a:xfrm>
-          <a:prstGeom prst="rect">
-            <a:avLst/>
-          </a:prstGeom>
-          <a:noFill/>
-        </p:spPr>
-        <p:txBody>
-          <a:bodyPr wrap="square" anchor="ctr">
-            <a:spAutoFit/>
-          </a:bodyPr>
-          <a:lstStyle/>
-          <a:p>
-            <a:pPr algn="ctr">
-              <a:defRPr sz="1800" b="1">
-                <a:solidFill>
-                  <a:srgbClr val="FFFFFF"/>
-                </a:solidFill>
-                <a:latin typeface="Calibri"/>
-              </a:defRPr>
-            </a:pPr>
-            <a:r>
-              <a:t>5</a:t>
-            </a:r>
-          </a:p>
-        </p:txBody>
-      </p:sp>
-      <p:sp>
-        <p:nvSpPr>
-          <p:cNvPr id="31" name="Rectangle 30"/>
-          <p:cNvSpPr/>
-          <p:nvPr/>
-        </p:nvSpPr>
-        <p:spPr>
-          <a:xfrm>
-            <a:off x="457200" y="5330952"/>
-            <a:ext cx="54864" cy="960120"/>
-          </a:xfrm>
-          <a:prstGeom prst="rect">
-            <a:avLst/>
-          </a:prstGeom>
-          <a:solidFill>
-            <a:srgbClr val="C8302F"/>
-          </a:solidFill>
-          <a:ln>
-            <a:noFill/>
-          </a:ln>
-        </p:spPr>
-        <p:style>
-          <a:lnRef idx="1">
-            <a:schemeClr val="accent1"/>
-          </a:lnRef>
-          <a:fillRef idx="3">
-            <a:schemeClr val="accent1"/>
-          </a:fillRef>
-          <a:effectRef idx="2">
-            <a:schemeClr val="accent1"/>
-          </a:effectRef>
-          <a:fontRef idx="minor">
-            <a:schemeClr val="lt1"/>
-          </a:fontRef>
-        </p:style>
-        <p:txBody>
-          <a:bodyPr rtlCol="0" anchor="ctr"/>
-          <a:lstStyle/>
-          <a:p>
-            <a:pPr algn="ctr"/>
-          </a:p>
-        </p:txBody>
-      </p:sp>
-      <p:sp>
-        <p:nvSpPr>
           <p:cNvPr id="32" name="TextBox 31"/>
           <p:cNvSpPr txBox="1"/>
           <p:nvPr/>
@@ -13053,7 +13154,7 @@
               </a:defRPr>
             </a:pPr>
             <a:r>
-              <a:t>Opportunity cost real — Birmingham recovered 9× more</a:t>
+              <a:t>Recovery real but slow — all subgroups still below pre-COVID</a:t>
             </a:r>
           </a:p>
         </p:txBody>
@@ -13625,7 +13726,7 @@
               </a:defRPr>
             </a:pPr>
             <a:r>
-              <a:t>Pre-COVID baseline: 2017–19 mean. Post-COVID: 2022–25 mean. IM window: 2022–23 → 2024–25 (the exact adoption period).</a:t>
+              <a:t>Pre-COVID baseline: 2017–19 mean. Post-COVID: 2022–25 mean. IM window: 2023 → 2025 (last pre-IM test to latest data).</a:t>
             </a:r>
           </a:p>
         </p:txBody>
@@ -16302,7 +16403,7 @@
               </a:defRPr>
             </a:pPr>
             <a:r>
-              <a:t>Troy Fell 59 Places in the National Math Rankings</a:t>
+              <a:t>COVID Erased Troy's Math Advantage</a:t>
             </a:r>
           </a:p>
         </p:txBody>
@@ -16338,7 +16439,7 @@
               </a:defRPr>
             </a:pPr>
             <a:r>
-              <a:t>From top-quarter to mid-pack among 296 level-matched peers</a:t>
+              <a:t>Pre-COVID #76 → Post-COVID #135 among 296 level-matched peers</a:t>
             </a:r>
           </a:p>
         </p:txBody>
@@ -16669,7 +16770,7 @@
               </a:defRPr>
             </a:pPr>
             <a:r>
-              <a:t>Peers at the same starting level pulled ahead</a:t>
+              <a:t>COVID hit Troy harder than most peers. This is the deficit IM inherited.</a:t>
             </a:r>
           </a:p>
         </p:txBody>
@@ -16774,7 +16875,7 @@
               </a:defRPr>
             </a:pPr>
             <a:r>
-              <a:t>MI Peer Leaderboard: Troy Fell From 2nd to 4th</a:t>
+              <a:t>MI Peer Leaderboard: Troy Holds at 4th in IM Window</a:t>
             </a:r>
           </a:p>
         </p:txBody>
@@ -16810,7 +16911,7 @@
               </a:defRPr>
             </a:pPr>
             <a:r>
-              <a:t>4 of 5 subgroups lost positions under IM + detracking</a:t>
+              <a:t>Rank unchanged from 2023 to 2025 — no ground gained or lost</a:t>
             </a:r>
           </a:p>
         </p:txBody>
@@ -17294,7 +17395,7 @@
               </a:defRPr>
             </a:pPr>
             <a:r>
-              <a:t>2nd→4th</a:t>
+              <a:t>4th→4th</a:t>
             </a:r>
           </a:p>
         </p:txBody>
@@ -17324,13 +17425,13 @@
             <a:pPr algn="ctr">
               <a:defRPr sz="1300" b="1">
                 <a:solidFill>
-                  <a:srgbClr val="C8302F"/>
-                </a:solidFill>
-                <a:latin typeface="Calibri"/>
-              </a:defRPr>
-            </a:pPr>
-            <a:r>
-              <a:t>−2</a:t>
+                  <a:srgbClr val="777777"/>
+                </a:solidFill>
+                <a:latin typeface="Calibri"/>
+              </a:defRPr>
+            </a:pPr>
+            <a:r>
+              <a:t>±0</a:t>
             </a:r>
           </a:p>
         </p:txBody>
@@ -17445,7 +17546,7 @@
               </a:defRPr>
             </a:pPr>
             <a:r>
-              <a:t>1st→2nd</a:t>
+              <a:t>3rd→3rd</a:t>
             </a:r>
           </a:p>
         </p:txBody>
@@ -17475,13 +17576,13 @@
             <a:pPr algn="ctr">
               <a:defRPr sz="1300" b="1">
                 <a:solidFill>
-                  <a:srgbClr val="C8302F"/>
-                </a:solidFill>
-                <a:latin typeface="Calibri"/>
-              </a:defRPr>
-            </a:pPr>
-            <a:r>
-              <a:t>−1</a:t>
+                  <a:srgbClr val="777777"/>
+                </a:solidFill>
+                <a:latin typeface="Calibri"/>
+              </a:defRPr>
+            </a:pPr>
+            <a:r>
+              <a:t>±0</a:t>
             </a:r>
           </a:p>
         </p:txBody>
@@ -17596,7 +17697,7 @@
               </a:defRPr>
             </a:pPr>
             <a:r>
-              <a:t>6th→5th</a:t>
+              <a:t>4th→5th</a:t>
             </a:r>
           </a:p>
         </p:txBody>
@@ -17626,13 +17727,13 @@
             <a:pPr algn="ctr">
               <a:defRPr sz="1300" b="1">
                 <a:solidFill>
-                  <a:srgbClr val="1F7A3D"/>
-                </a:solidFill>
-                <a:latin typeface="Calibri"/>
-              </a:defRPr>
-            </a:pPr>
-            <a:r>
-              <a:t>+1</a:t>
+                  <a:srgbClr val="C8302F"/>
+                </a:solidFill>
+                <a:latin typeface="Calibri"/>
+              </a:defRPr>
+            </a:pPr>
+            <a:r>
+              <a:t>−1</a:t>
             </a:r>
           </a:p>
         </p:txBody>
@@ -17747,7 +17848,7 @@
               </a:defRPr>
             </a:pPr>
             <a:r>
-              <a:t>3rd→4th</a:t>
+              <a:t>3rd→3rd</a:t>
             </a:r>
           </a:p>
         </p:txBody>
@@ -17777,13 +17878,13 @@
             <a:pPr algn="ctr">
               <a:defRPr sz="1300" b="1">
                 <a:solidFill>
-                  <a:srgbClr val="C8302F"/>
-                </a:solidFill>
-                <a:latin typeface="Calibri"/>
-              </a:defRPr>
-            </a:pPr>
-            <a:r>
-              <a:t>−1</a:t>
+                  <a:srgbClr val="777777"/>
+                </a:solidFill>
+                <a:latin typeface="Calibri"/>
+              </a:defRPr>
+            </a:pPr>
+            <a:r>
+              <a:t>±0</a:t>
             </a:r>
           </a:p>
         </p:txBody>
@@ -17898,7 +17999,7 @@
               </a:defRPr>
             </a:pPr>
             <a:r>
-              <a:t>2nd→3rd</a:t>
+              <a:t>3rd→3rd</a:t>
             </a:r>
           </a:p>
         </p:txBody>
@@ -17928,13 +18029,13 @@
             <a:pPr algn="ctr">
               <a:defRPr sz="1300" b="1">
                 <a:solidFill>
-                  <a:srgbClr val="C8302F"/>
-                </a:solidFill>
-                <a:latin typeface="Calibri"/>
-              </a:defRPr>
-            </a:pPr>
-            <a:r>
-              <a:t>−1</a:t>
+                  <a:srgbClr val="777777"/>
+                </a:solidFill>
+                <a:latin typeface="Calibri"/>
+              </a:defRPr>
+            </a:pPr>
+            <a:r>
+              <a:t>±0</a:t>
             </a:r>
           </a:p>
         </p:txBody>
@@ -17962,19 +18063,19 @@
           <a:lstStyle/>
           <a:p>
             <a:pPr algn="l">
-              <a:defRPr sz="1300" b="1">
-                <a:solidFill>
-                  <a:srgbClr val="C8302F"/>
-                </a:solidFill>
-                <a:latin typeface="Calibri"/>
-              </a:defRPr>
-            </a:pPr>
-            <a:r>
-              <a:t>Was #1 Asian math in MI.</a:t>
+              <a:defRPr sz="1200" b="1">
+                <a:solidFill>
+                  <a:srgbClr val="B7791F"/>
+                </a:solidFill>
+                <a:latin typeface="Calibri"/>
+              </a:defRPr>
+            </a:pPr>
+            <a:r>
+              <a:t>White subgroup dropped one spot (4th→5th).</a:t>
             </a:r>
             <a:br/>
             <a:r>
-              <a:t>Northville now leads.</a:t>
+              <a:t>Rank stability = not closing the gap.</a:t>
             </a:r>
           </a:p>
         </p:txBody>
@@ -18079,7 +18180,7 @@
               </a:defRPr>
             </a:pPr>
             <a:r>
-              <a:t>The Post-COVID Decline Hit Troy Hard in Math</a:t>
+              <a:t>IM-Window Recovery: Troy Mid-Pack Among 22 Districts</a:t>
             </a:r>
           </a:p>
         </p:txBody>
@@ -18115,7 +18216,7 @@
               </a:defRPr>
             </a:pPr>
             <a:r>
-              <a:t>Troy declined −0.187 grade levels — rank 104 of 296 (35th percentile)</a:t>
+              <a:t>Troy +0.076 — 13th of 22 analysis districts (2023 → 2025)</a:t>
             </a:r>
           </a:p>
         </p:txBody>
@@ -18274,7 +18375,7 @@
             <a:avLst/>
           </a:prstGeom>
           <a:solidFill>
-            <a:srgbClr val="FBE7E6"/>
+            <a:srgbClr val="FFF4E0"/>
           </a:solidFill>
           <a:ln>
             <a:noFill/>
@@ -18327,13 +18428,13 @@
             <a:pPr algn="l">
               <a:defRPr sz="3200" b="1">
                 <a:solidFill>
-                  <a:srgbClr val="C8302F"/>
-                </a:solidFill>
-                <a:latin typeface="Calibri"/>
-              </a:defRPr>
-            </a:pPr>
-            <a:r>
-              <a:t>−0.187</a:t>
+                  <a:srgbClr val="B7791F"/>
+                </a:solidFill>
+                <a:latin typeface="Calibri"/>
+              </a:defRPr>
+            </a:pPr>
+            <a:r>
+              <a:t>+0.076</a:t>
             </a:r>
           </a:p>
         </p:txBody>
@@ -18372,7 +18473,7 @@
               </a:defRPr>
             </a:pPr>
             <a:r>
-              <a:t>grade-level decline</a:t>
+              <a:t>grade-level recovery</a:t>
             </a:r>
           </a:p>
           <a:p>
@@ -18387,6 +18488,9 @@
                 <a:latin typeface="Calibri"/>
               </a:defRPr>
             </a:pPr>
+            <a:r>
+              <a:t>(2023 → 2025)</a:t>
+            </a:r>
           </a:p>
           <a:p>
             <a:pPr algn="l">
@@ -18400,9 +18504,6 @@
                 <a:latin typeface="Calibri"/>
               </a:defRPr>
             </a:pPr>
-            <a:r>
-              <a:t>Rank 104 of 296</a:t>
-            </a:r>
           </a:p>
           <a:p>
             <a:pPr algn="l">
@@ -18417,7 +18518,7 @@
               </a:defRPr>
             </a:pPr>
             <a:r>
-              <a:t>(35th percentile)</a:t>
+              <a:t>Rank 13 / 22</a:t>
             </a:r>
           </a:p>
           <a:p>
@@ -18432,6 +18533,9 @@
                 <a:latin typeface="Calibri"/>
               </a:defRPr>
             </a:pPr>
+            <a:r>
+              <a:t>mid-pack among analysis districts</a:t>
+            </a:r>
           </a:p>
           <a:p>
             <a:pPr algn="l">
@@ -18445,8 +18549,21 @@
                 <a:latin typeface="Calibri"/>
               </a:defRPr>
             </a:pPr>
-            <a:r>
-              <a:t>3rd worst among 8 MI peers</a:t>
+          </a:p>
+          <a:p>
+            <a:pPr algn="l">
+              <a:spcAft>
+                <a:spcPts val="600"/>
+              </a:spcAft>
+              <a:defRPr sz="1500" b="0">
+                <a:solidFill>
+                  <a:srgbClr val="333333"/>
+                </a:solidFill>
+                <a:latin typeface="Calibri"/>
+              </a:defRPr>
+            </a:pPr>
+            <a:r>
+              <a:t>6th of 8 MI peers</a:t>
             </a:r>
           </a:p>
         </p:txBody>
@@ -18551,7 +18668,7 @@
               </a:defRPr>
             </a:pPr>
             <a:r>
-              <a:t>The Critical Test: Recovery During the IM Window (2022–23 → 2024–25)</a:t>
+              <a:t>The Critical Test: Recovery During the IM Window</a:t>
             </a:r>
           </a:p>
         </p:txBody>
@@ -18587,7 +18704,7 @@
               </a:defRPr>
             </a:pPr>
             <a:r>
-              <a:t>If IM were working, Troy should show stronger-than-peer recovery</a:t>
+              <a:t>296-peer ranking of IM-window recovery — Troy in the bottom third</a:t>
             </a:r>
           </a:p>
         </p:txBody>
@@ -19066,7 +19183,7 @@
               </a:defRPr>
             </a:pPr>
             <a:r>
-              <a:t>Birmingham (tracked) recovered 9× more than Troy (IM + detracked)</a:t>
+              <a:t>Novi leads with 1.6× more recovery; Troy trails the median</a:t>
             </a:r>
           </a:p>
         </p:txBody>
@@ -19320,7 +19437,7 @@
               </a:defRPr>
             </a:pPr>
             <a:r>
-              <a:t>Birmingham</a:t>
+              <a:t>Novi</a:t>
             </a:r>
           </a:p>
         </p:txBody>
@@ -19356,7 +19473,7 @@
               </a:defRPr>
             </a:pPr>
             <a:r>
-              <a:t>+0.211</a:t>
+              <a:t>+0.123</a:t>
             </a:r>
           </a:p>
         </p:txBody>
@@ -19364,42 +19481,6 @@
       <p:sp>
         <p:nvSpPr>
           <p:cNvPr id="13" name="TextBox 12"/>
-          <p:cNvSpPr txBox="1"/>
-          <p:nvPr/>
-        </p:nvSpPr>
-        <p:spPr>
-          <a:xfrm>
-            <a:off x="10104120" y="1563624"/>
-            <a:ext cx="1645920" cy="365760"/>
-          </a:xfrm>
-          <a:prstGeom prst="rect">
-            <a:avLst/>
-          </a:prstGeom>
-          <a:noFill/>
-        </p:spPr>
-        <p:txBody>
-          <a:bodyPr wrap="square" anchor="t">
-            <a:spAutoFit/>
-          </a:bodyPr>
-          <a:lstStyle/>
-          <a:p>
-            <a:pPr algn="l">
-              <a:defRPr sz="1100" b="0">
-                <a:solidFill>
-                  <a:srgbClr val="777777"/>
-                </a:solidFill>
-                <a:latin typeface="Calibri"/>
-              </a:defRPr>
-            </a:pPr>
-            <a:r>
-              <a:t>(tracked)</a:t>
-            </a:r>
-          </a:p>
-        </p:txBody>
-      </p:sp>
-      <p:sp>
-        <p:nvSpPr>
-          <p:cNvPr id="14" name="TextBox 13"/>
           <p:cNvSpPr txBox="1"/>
           <p:nvPr/>
         </p:nvSpPr>
@@ -19428,14 +19509,14 @@
               </a:defRPr>
             </a:pPr>
             <a:r>
-              <a:t>Northville</a:t>
-            </a:r>
-          </a:p>
-        </p:txBody>
-      </p:sp>
-      <p:sp>
-        <p:nvSpPr>
-          <p:cNvPr id="15" name="TextBox 14"/>
+              <a:t>Birmingham</a:t>
+            </a:r>
+          </a:p>
+        </p:txBody>
+      </p:sp>
+      <p:sp>
+        <p:nvSpPr>
+          <p:cNvPr id="14" name="TextBox 13"/>
           <p:cNvSpPr txBox="1"/>
           <p:nvPr/>
         </p:nvSpPr>
@@ -19464,14 +19545,14 @@
               </a:defRPr>
             </a:pPr>
             <a:r>
-              <a:t>+0.102</a:t>
-            </a:r>
-          </a:p>
-        </p:txBody>
-      </p:sp>
-      <p:sp>
-        <p:nvSpPr>
-          <p:cNvPr id="16" name="TextBox 15"/>
+              <a:t>+0.095</a:t>
+            </a:r>
+          </a:p>
+        </p:txBody>
+      </p:sp>
+      <p:sp>
+        <p:nvSpPr>
+          <p:cNvPr id="15" name="TextBox 14"/>
           <p:cNvSpPr txBox="1"/>
           <p:nvPr/>
         </p:nvSpPr>
@@ -19507,7 +19588,7 @@
       </p:sp>
       <p:sp>
         <p:nvSpPr>
-          <p:cNvPr id="17" name="TextBox 16"/>
+          <p:cNvPr id="16" name="TextBox 15"/>
           <p:cNvSpPr txBox="1"/>
           <p:nvPr/>
         </p:nvSpPr>
@@ -19536,14 +19617,14 @@
               </a:defRPr>
             </a:pPr>
             <a:r>
-              <a:t>Bloomfield Hills</a:t>
-            </a:r>
-          </a:p>
-        </p:txBody>
-      </p:sp>
-      <p:sp>
-        <p:nvSpPr>
-          <p:cNvPr id="18" name="TextBox 17"/>
+              <a:t>Northville</a:t>
+            </a:r>
+          </a:p>
+        </p:txBody>
+      </p:sp>
+      <p:sp>
+        <p:nvSpPr>
+          <p:cNvPr id="17" name="TextBox 16"/>
           <p:cNvSpPr txBox="1"/>
           <p:nvPr/>
         </p:nvSpPr>
@@ -19579,7 +19660,7 @@
       </p:sp>
       <p:sp>
         <p:nvSpPr>
-          <p:cNvPr id="19" name="TextBox 18"/>
+          <p:cNvPr id="18" name="TextBox 17"/>
           <p:cNvSpPr txBox="1"/>
           <p:nvPr/>
         </p:nvSpPr>
@@ -19615,7 +19696,7 @@
       </p:sp>
       <p:sp>
         <p:nvSpPr>
-          <p:cNvPr id="20" name="TextBox 19"/>
+          <p:cNvPr id="19" name="TextBox 18"/>
           <p:cNvSpPr txBox="1"/>
           <p:nvPr/>
         </p:nvSpPr>
@@ -19644,14 +19725,14 @@
               </a:defRPr>
             </a:pPr>
             <a:r>
-              <a:t>Walled Lake</a:t>
-            </a:r>
-          </a:p>
-        </p:txBody>
-      </p:sp>
-      <p:sp>
-        <p:nvSpPr>
-          <p:cNvPr id="21" name="TextBox 20"/>
+              <a:t>Rochester</a:t>
+            </a:r>
+          </a:p>
+        </p:txBody>
+      </p:sp>
+      <p:sp>
+        <p:nvSpPr>
+          <p:cNvPr id="20" name="TextBox 19"/>
           <p:cNvSpPr txBox="1"/>
           <p:nvPr/>
         </p:nvSpPr>
@@ -19680,14 +19761,14 @@
               </a:defRPr>
             </a:pPr>
             <a:r>
-              <a:t>+0.056</a:t>
-            </a:r>
-          </a:p>
-        </p:txBody>
-      </p:sp>
-      <p:sp>
-        <p:nvSpPr>
-          <p:cNvPr id="22" name="TextBox 21"/>
+              <a:t>+0.080</a:t>
+            </a:r>
+          </a:p>
+        </p:txBody>
+      </p:sp>
+      <p:sp>
+        <p:nvSpPr>
+          <p:cNvPr id="21" name="TextBox 20"/>
           <p:cNvSpPr txBox="1"/>
           <p:nvPr/>
         </p:nvSpPr>
@@ -19710,20 +19791,20 @@
             <a:pPr algn="l">
               <a:defRPr sz="1300" b="0">
                 <a:solidFill>
-                  <a:srgbClr val="333333"/>
-                </a:solidFill>
-                <a:latin typeface="Calibri"/>
-              </a:defRPr>
-            </a:pPr>
-            <a:r>
-              <a:t>Novi</a:t>
-            </a:r>
-          </a:p>
-        </p:txBody>
-      </p:sp>
-      <p:sp>
-        <p:nvSpPr>
-          <p:cNvPr id="23" name="TextBox 22"/>
+                  <a:srgbClr val="1F7A3D"/>
+                </a:solidFill>
+                <a:latin typeface="Calibri"/>
+              </a:defRPr>
+            </a:pPr>
+            <a:r>
+              <a:t>Bloomfield Hills</a:t>
+            </a:r>
+          </a:p>
+        </p:txBody>
+      </p:sp>
+      <p:sp>
+        <p:nvSpPr>
+          <p:cNvPr id="22" name="TextBox 21"/>
           <p:cNvSpPr txBox="1"/>
           <p:nvPr/>
         </p:nvSpPr>
@@ -19746,13 +19827,49 @@
             <a:pPr algn="l">
               <a:defRPr sz="1300" b="1">
                 <a:solidFill>
-                  <a:srgbClr val="333333"/>
-                </a:solidFill>
-                <a:latin typeface="Calibri"/>
-              </a:defRPr>
-            </a:pPr>
-            <a:r>
-              <a:t>+0.029</a:t>
+                  <a:srgbClr val="1F7A3D"/>
+                </a:solidFill>
+                <a:latin typeface="Calibri"/>
+              </a:defRPr>
+            </a:pPr>
+            <a:r>
+              <a:t>+0.079</a:t>
+            </a:r>
+          </a:p>
+        </p:txBody>
+      </p:sp>
+      <p:sp>
+        <p:nvSpPr>
+          <p:cNvPr id="23" name="TextBox 22"/>
+          <p:cNvSpPr txBox="1"/>
+          <p:nvPr/>
+        </p:nvSpPr>
+        <p:spPr>
+          <a:xfrm>
+            <a:off x="10104120" y="3611880"/>
+            <a:ext cx="1645920" cy="365760"/>
+          </a:xfrm>
+          <a:prstGeom prst="rect">
+            <a:avLst/>
+          </a:prstGeom>
+          <a:noFill/>
+        </p:spPr>
+        <p:txBody>
+          <a:bodyPr wrap="square" anchor="t">
+            <a:spAutoFit/>
+          </a:bodyPr>
+          <a:lstStyle/>
+          <a:p>
+            <a:pPr algn="l">
+              <a:defRPr sz="1100" b="0">
+                <a:solidFill>
+                  <a:srgbClr val="777777"/>
+                </a:solidFill>
+                <a:latin typeface="Calibri"/>
+              </a:defRPr>
+            </a:pPr>
+            <a:r>
+              <a:t>(tracked)</a:t>
             </a:r>
           </a:p>
         </p:txBody>
@@ -19867,7 +19984,7 @@
               </a:defRPr>
             </a:pPr>
             <a:r>
-              <a:t>+0.024</a:t>
+              <a:t>+0.076</a:t>
             </a:r>
           </a:p>
         </p:txBody>
@@ -19939,7 +20056,7 @@
               </a:defRPr>
             </a:pPr>
             <a:r>
-              <a:t>Rochester</a:t>
+              <a:t>West Bloomfield</a:t>
             </a:r>
           </a:p>
         </p:txBody>
@@ -19975,7 +20092,7 @@
               </a:defRPr>
             </a:pPr>
             <a:r>
-              <a:t>+0.000</a:t>
+              <a:t>+0.039</a:t>
             </a:r>
           </a:p>
         </p:txBody>
@@ -20011,7 +20128,7 @@
               </a:defRPr>
             </a:pPr>
             <a:r>
-              <a:t>West Bloomfield</a:t>
+              <a:t>Walled Lake</a:t>
             </a:r>
           </a:p>
         </p:txBody>
@@ -20047,7 +20164,7 @@
               </a:defRPr>
             </a:pPr>
             <a:r>
-              <a:t>+0.006</a:t>
+              <a:t>+0.016</a:t>
             </a:r>
           </a:p>
         </p:txBody>

</xml_diff>

<commit_message>
Match K-5 ELA design; add SEDA national ranking appendix (slide 20)
Align color palette to K-5 ELA deck: ACCENT_RED #B02121,
ACCENT_ORANGE #CC6A11, SUBTITLE #CCDDEE, GRAY_MID #707070,
GRAY_LIGHT #EEEEEE, LIGHT_RED #FCE4E4, LIGHT_GREEN #E6F4E8.
Chart colors updated to match.

Add slide 20 (Appendix) with SEDA national ranking analysis:
- National G6+G7 math ranking trajectory (top 2% to top 4%)
- Pre/post-COVID scatter plot (296 level-matched peers)
- MI affluent peer score deltas (Birmingham +0.131 to Walled Lake -0.197)
- 70 districts leapfrogged Troy (rank 76 to 135 among peers)

Co-Authored-By: Claude Opus 4.6 <noreply@anthropic.com>
</commit_message>
<xml_diff>
--- a/deck/Troy_G6G7_Math_Executive_Summary.pptx
+++ b/deck/Troy_G6G7_Math_Executive_Summary.pptx
@@ -24,6 +24,7 @@
     <p:sldId id="272" r:id="rId23"/>
     <p:sldId id="273" r:id="rId24"/>
     <p:sldId id="274" r:id="rId25"/>
+    <p:sldId id="275" r:id="rId26"/>
   </p:sldIdLst>
   <p:sldSz cx="12191695" cy="6858000" type="screen4x3"/>
   <p:notesSz cx="6858000" cy="9144000"/>
@@ -3333,7 +3334,7 @@
             <a:pPr algn="l">
               <a:defRPr sz="1100" b="0">
                 <a:solidFill>
-                  <a:srgbClr val="A0B4CC"/>
+                  <a:srgbClr val="CCDDEE"/>
                 </a:solidFill>
                 <a:latin typeface="Calibri"/>
               </a:defRPr>
@@ -3369,7 +3370,7 @@
             <a:pPr algn="l">
               <a:defRPr sz="1100" b="0">
                 <a:solidFill>
-                  <a:srgbClr val="A0B4CC"/>
+                  <a:srgbClr val="CCDDEE"/>
                 </a:solidFill>
                 <a:latin typeface="Calibri"/>
               </a:defRPr>
@@ -3490,7 +3491,7 @@
               </a:defRPr>
             </a:pPr>
             <a:r>
-              <a:t>1 / 19</a:t>
+              <a:t>1 / 20</a:t>
             </a:r>
           </a:p>
         </p:txBody>
@@ -3625,7 +3626,7 @@
             <a:pPr algn="l">
               <a:defRPr sz="1200" b="0">
                 <a:solidFill>
-                  <a:srgbClr val="A0B4CC"/>
+                  <a:srgbClr val="CCDDEE"/>
                 </a:solidFill>
                 <a:latin typeface="Calibri"/>
               </a:defRPr>
@@ -3746,7 +3747,7 @@
               </a:defRPr>
             </a:pPr>
             <a:r>
-              <a:t>10 / 19</a:t>
+              <a:t>10 / 20</a:t>
             </a:r>
           </a:p>
         </p:txBody>
@@ -3790,7 +3791,7 @@
             <a:avLst/>
           </a:prstGeom>
           <a:solidFill>
-            <a:srgbClr val="E8F5EE"/>
+            <a:srgbClr val="E6F4E8"/>
           </a:solidFill>
           <a:ln>
             <a:noFill/>
@@ -3905,7 +3906,7 @@
             <a:avLst/>
           </a:prstGeom>
           <a:solidFill>
-            <a:srgbClr val="E8F5EE"/>
+            <a:srgbClr val="E6F4E8"/>
           </a:solidFill>
           <a:ln>
             <a:noFill/>
@@ -4135,7 +4136,7 @@
             <a:pPr algn="l">
               <a:defRPr sz="1200" b="0">
                 <a:solidFill>
-                  <a:srgbClr val="A0B4CC"/>
+                  <a:srgbClr val="CCDDEE"/>
                 </a:solidFill>
                 <a:latin typeface="Calibri"/>
               </a:defRPr>
@@ -4256,7 +4257,7 @@
               </a:defRPr>
             </a:pPr>
             <a:r>
-              <a:t>11 / 19</a:t>
+              <a:t>11 / 20</a:t>
             </a:r>
           </a:p>
         </p:txBody>
@@ -4300,7 +4301,7 @@
             <a:avLst/>
           </a:prstGeom>
           <a:solidFill>
-            <a:srgbClr val="F2F4F7"/>
+            <a:srgbClr val="EEEEEE"/>
           </a:solidFill>
           <a:ln>
             <a:noFill/>
@@ -4497,7 +4498,7 @@
             <a:pPr algn="l">
               <a:defRPr sz="3000" b="1">
                 <a:solidFill>
-                  <a:srgbClr val="C8302F"/>
+                  <a:srgbClr val="B02121"/>
                 </a:solidFill>
                 <a:latin typeface="Calibri"/>
               </a:defRPr>
@@ -4605,7 +4606,7 @@
             <a:pPr algn="l">
               <a:defRPr sz="3000" b="1">
                 <a:solidFill>
-                  <a:srgbClr val="B7791F"/>
+                  <a:srgbClr val="CC6A11"/>
                 </a:solidFill>
                 <a:latin typeface="Calibri"/>
               </a:defRPr>
@@ -4782,7 +4783,7 @@
             <a:pPr algn="l">
               <a:defRPr sz="1200" b="0">
                 <a:solidFill>
-                  <a:srgbClr val="A0B4CC"/>
+                  <a:srgbClr val="CCDDEE"/>
                 </a:solidFill>
                 <a:latin typeface="Calibri"/>
               </a:defRPr>
@@ -4903,7 +4904,7 @@
               </a:defRPr>
             </a:pPr>
             <a:r>
-              <a:t>12 / 19</a:t>
+              <a:t>12 / 20</a:t>
             </a:r>
           </a:p>
         </p:txBody>
@@ -4947,7 +4948,7 @@
             <a:avLst/>
           </a:prstGeom>
           <a:solidFill>
-            <a:srgbClr val="E8F5EE"/>
+            <a:srgbClr val="E6F4E8"/>
           </a:solidFill>
           <a:ln>
             <a:noFill/>
@@ -5062,7 +5063,7 @@
             <a:avLst/>
           </a:prstGeom>
           <a:solidFill>
-            <a:srgbClr val="E8F5EE"/>
+            <a:srgbClr val="E6F4E8"/>
           </a:solidFill>
           <a:ln>
             <a:noFill/>
@@ -5177,7 +5178,7 @@
             <a:avLst/>
           </a:prstGeom>
           <a:solidFill>
-            <a:srgbClr val="FBE7E6"/>
+            <a:srgbClr val="FCE4E4"/>
           </a:solidFill>
           <a:ln>
             <a:noFill/>
@@ -5266,7 +5267,7 @@
             <a:pPr algn="l">
               <a:defRPr sz="3000" b="1">
                 <a:solidFill>
-                  <a:srgbClr val="C8302F"/>
+                  <a:srgbClr val="B02121"/>
                 </a:solidFill>
                 <a:latin typeface="Calibri"/>
               </a:defRPr>
@@ -5407,7 +5408,7 @@
             <a:pPr algn="l">
               <a:defRPr sz="1200" b="0">
                 <a:solidFill>
-                  <a:srgbClr val="A0B4CC"/>
+                  <a:srgbClr val="CCDDEE"/>
                 </a:solidFill>
                 <a:latin typeface="Calibri"/>
               </a:defRPr>
@@ -5528,7 +5529,7 @@
               </a:defRPr>
             </a:pPr>
             <a:r>
-              <a:t>13 / 19</a:t>
+              <a:t>13 / 20</a:t>
             </a:r>
           </a:p>
         </p:txBody>
@@ -5572,7 +5573,7 @@
             <a:avLst/>
           </a:prstGeom>
           <a:solidFill>
-            <a:srgbClr val="F2F4F7"/>
+            <a:srgbClr val="EEEEEE"/>
           </a:solidFill>
           <a:ln>
             <a:noFill/>
@@ -5921,7 +5922,7 @@
             <a:pPr algn="l">
               <a:defRPr sz="1200" b="0">
                 <a:solidFill>
-                  <a:srgbClr val="A0B4CC"/>
+                  <a:srgbClr val="CCDDEE"/>
                 </a:solidFill>
                 <a:latin typeface="Calibri"/>
               </a:defRPr>
@@ -6042,7 +6043,7 @@
               </a:defRPr>
             </a:pPr>
             <a:r>
-              <a:t>14 / 19</a:t>
+              <a:t>14 / 20</a:t>
             </a:r>
           </a:p>
         </p:txBody>
@@ -6086,7 +6087,7 @@
             <a:avLst/>
           </a:prstGeom>
           <a:solidFill>
-            <a:srgbClr val="F2F4F7"/>
+            <a:srgbClr val="EEEEEE"/>
           </a:solidFill>
           <a:ln>
             <a:noFill/>
@@ -6611,7 +6612,7 @@
             <a:avLst/>
           </a:prstGeom>
           <a:solidFill>
-            <a:srgbClr val="F2F4F7"/>
+            <a:srgbClr val="EEEEEE"/>
           </a:solidFill>
           <a:ln>
             <a:noFill/>
@@ -6834,7 +6835,7 @@
             <a:avLst/>
           </a:prstGeom>
           <a:solidFill>
-            <a:srgbClr val="FBE7E6"/>
+            <a:srgbClr val="FCE4E4"/>
           </a:solidFill>
           <a:ln>
             <a:noFill/>
@@ -6877,7 +6878,7 @@
             <a:avLst/>
           </a:prstGeom>
           <a:solidFill>
-            <a:srgbClr val="C8302F"/>
+            <a:srgbClr val="B02121"/>
           </a:solidFill>
           <a:ln>
             <a:noFill/>
@@ -6930,7 +6931,7 @@
             <a:pPr algn="l">
               <a:defRPr sz="1400" b="1">
                 <a:solidFill>
-                  <a:srgbClr val="C8302F"/>
+                  <a:srgbClr val="B02121"/>
                 </a:solidFill>
                 <a:latin typeface="Calibri"/>
               </a:defRPr>
@@ -7071,7 +7072,7 @@
             <a:pPr algn="l">
               <a:defRPr sz="1200" b="0">
                 <a:solidFill>
-                  <a:srgbClr val="A0B4CC"/>
+                  <a:srgbClr val="CCDDEE"/>
                 </a:solidFill>
                 <a:latin typeface="Calibri"/>
               </a:defRPr>
@@ -7192,7 +7193,7 @@
               </a:defRPr>
             </a:pPr>
             <a:r>
-              <a:t>15 / 19</a:t>
+              <a:t>15 / 20</a:t>
             </a:r>
           </a:p>
         </p:txBody>
@@ -7255,7 +7256,7 @@
             <a:avLst/>
           </a:prstGeom>
           <a:solidFill>
-            <a:srgbClr val="B7791F"/>
+            <a:srgbClr val="CC6A11"/>
           </a:solidFill>
           <a:ln>
             <a:noFill/>
@@ -7298,7 +7299,7 @@
             <a:avLst/>
           </a:prstGeom>
           <a:solidFill>
-            <a:srgbClr val="B7791F"/>
+            <a:srgbClr val="CC6A11"/>
           </a:solidFill>
           <a:ln>
             <a:noFill/>
@@ -7456,7 +7457,7 @@
             <a:avLst/>
           </a:prstGeom>
           <a:solidFill>
-            <a:srgbClr val="B7791F"/>
+            <a:srgbClr val="CC6A11"/>
           </a:solidFill>
           <a:ln>
             <a:noFill/>
@@ -7499,7 +7500,7 @@
             <a:avLst/>
           </a:prstGeom>
           <a:solidFill>
-            <a:srgbClr val="B7791F"/>
+            <a:srgbClr val="CC6A11"/>
           </a:solidFill>
           <a:ln>
             <a:noFill/>
@@ -7657,7 +7658,7 @@
             <a:avLst/>
           </a:prstGeom>
           <a:solidFill>
-            <a:srgbClr val="B7791F"/>
+            <a:srgbClr val="CC6A11"/>
           </a:solidFill>
           <a:ln>
             <a:noFill/>
@@ -7700,7 +7701,7 @@
             <a:avLst/>
           </a:prstGeom>
           <a:solidFill>
-            <a:srgbClr val="B7791F"/>
+            <a:srgbClr val="CC6A11"/>
           </a:solidFill>
           <a:ln>
             <a:noFill/>
@@ -7930,7 +7931,7 @@
             <a:pPr algn="l">
               <a:defRPr sz="1200" b="0">
                 <a:solidFill>
-                  <a:srgbClr val="A0B4CC"/>
+                  <a:srgbClr val="CCDDEE"/>
                 </a:solidFill>
                 <a:latin typeface="Calibri"/>
               </a:defRPr>
@@ -8051,7 +8052,7 @@
               </a:defRPr>
             </a:pPr>
             <a:r>
-              <a:t>16 / 19</a:t>
+              <a:t>16 / 20</a:t>
             </a:r>
           </a:p>
         </p:txBody>
@@ -8095,7 +8096,7 @@
             <a:avLst/>
           </a:prstGeom>
           <a:solidFill>
-            <a:srgbClr val="E8F5EE"/>
+            <a:srgbClr val="E6F4E8"/>
           </a:solidFill>
           <a:ln>
             <a:noFill/>
@@ -8415,7 +8416,7 @@
             <a:pPr algn="l">
               <a:defRPr sz="1200" b="0">
                 <a:solidFill>
-                  <a:srgbClr val="A0B4CC"/>
+                  <a:srgbClr val="CCDDEE"/>
                 </a:solidFill>
                 <a:latin typeface="Calibri"/>
               </a:defRPr>
@@ -8536,7 +8537,7 @@
               </a:defRPr>
             </a:pPr>
             <a:r>
-              <a:t>17 / 19</a:t>
+              <a:t>17 / 20</a:t>
             </a:r>
           </a:p>
         </p:txBody>
@@ -8599,7 +8600,7 @@
             <a:avLst/>
           </a:prstGeom>
           <a:solidFill>
-            <a:srgbClr val="B7791F"/>
+            <a:srgbClr val="CC6A11"/>
           </a:solidFill>
           <a:ln>
             <a:noFill/>
@@ -8678,7 +8679,7 @@
             <a:avLst/>
           </a:prstGeom>
           <a:solidFill>
-            <a:srgbClr val="B7791F"/>
+            <a:srgbClr val="CC6A11"/>
           </a:solidFill>
           <a:ln>
             <a:noFill/>
@@ -8757,7 +8758,7 @@
             <a:avLst/>
           </a:prstGeom>
           <a:solidFill>
-            <a:srgbClr val="FBE7E6"/>
+            <a:srgbClr val="FCE4E4"/>
           </a:solidFill>
           <a:ln>
             <a:noFill/>
@@ -8800,7 +8801,7 @@
             <a:avLst/>
           </a:prstGeom>
           <a:solidFill>
-            <a:srgbClr val="C8302F"/>
+            <a:srgbClr val="B02121"/>
           </a:solidFill>
           <a:ln>
             <a:noFill/>
@@ -8879,7 +8880,7 @@
             <a:avLst/>
           </a:prstGeom>
           <a:solidFill>
-            <a:srgbClr val="C8302F"/>
+            <a:srgbClr val="B02121"/>
           </a:solidFill>
           <a:ln>
             <a:noFill/>
@@ -8958,7 +8959,7 @@
             <a:avLst/>
           </a:prstGeom>
           <a:solidFill>
-            <a:srgbClr val="E8F5EE"/>
+            <a:srgbClr val="E6F4E8"/>
           </a:solidFill>
           <a:ln>
             <a:noFill/>
@@ -9202,7 +9203,7 @@
             <a:avLst/>
           </a:prstGeom>
           <a:solidFill>
-            <a:srgbClr val="B7791F"/>
+            <a:srgbClr val="CC6A11"/>
           </a:solidFill>
           <a:ln>
             <a:noFill/>
@@ -9281,7 +9282,7 @@
             <a:avLst/>
           </a:prstGeom>
           <a:solidFill>
-            <a:srgbClr val="B7791F"/>
+            <a:srgbClr val="CC6A11"/>
           </a:solidFill>
           <a:ln>
             <a:noFill/>
@@ -9475,7 +9476,7 @@
             <a:pPr algn="l">
               <a:defRPr sz="1200" b="0">
                 <a:solidFill>
-                  <a:srgbClr val="A0B4CC"/>
+                  <a:srgbClr val="CCDDEE"/>
                 </a:solidFill>
                 <a:latin typeface="Calibri"/>
               </a:defRPr>
@@ -9596,7 +9597,7 @@
               </a:defRPr>
             </a:pPr>
             <a:r>
-              <a:t>18 / 19</a:t>
+              <a:t>18 / 20</a:t>
             </a:r>
           </a:p>
         </p:txBody>
@@ -10363,7 +10364,7 @@
             <a:pPr algn="l">
               <a:defRPr sz="1200" b="0">
                 <a:solidFill>
-                  <a:srgbClr val="A0B4CC"/>
+                  <a:srgbClr val="CCDDEE"/>
                 </a:solidFill>
                 <a:latin typeface="Calibri"/>
               </a:defRPr>
@@ -10484,7 +10485,7 @@
               </a:defRPr>
             </a:pPr>
             <a:r>
-              <a:t>19 / 19</a:t>
+              <a:t>19 / 20</a:t>
             </a:r>
           </a:p>
         </p:txBody>
@@ -10619,7 +10620,7 @@
             <a:avLst/>
           </a:prstGeom>
           <a:solidFill>
-            <a:srgbClr val="F2F4F7"/>
+            <a:srgbClr val="EEEEEE"/>
           </a:solidFill>
           <a:ln>
             <a:noFill/>
@@ -10964,7 +10965,7 @@
             <a:pPr algn="l">
               <a:defRPr sz="1200" b="0">
                 <a:solidFill>
-                  <a:srgbClr val="A0B4CC"/>
+                  <a:srgbClr val="CCDDEE"/>
                 </a:solidFill>
                 <a:latin typeface="Calibri"/>
               </a:defRPr>
@@ -11085,7 +11086,7 @@
               </a:defRPr>
             </a:pPr>
             <a:r>
-              <a:t>2 / 19</a:t>
+              <a:t>2 / 20</a:t>
             </a:r>
           </a:p>
         </p:txBody>
@@ -11220,7 +11221,7 @@
             <a:avLst/>
           </a:prstGeom>
           <a:solidFill>
-            <a:srgbClr val="FBE7E6"/>
+            <a:srgbClr val="FCE4E4"/>
           </a:solidFill>
           <a:ln>
             <a:noFill/>
@@ -11273,7 +11274,7 @@
             <a:pPr algn="l">
               <a:defRPr sz="1300" b="1">
                 <a:solidFill>
-                  <a:srgbClr val="C8302F"/>
+                  <a:srgbClr val="B02121"/>
                 </a:solidFill>
                 <a:latin typeface="Calibri"/>
               </a:defRPr>
@@ -11309,7 +11310,7 @@
             <a:pPr algn="l">
               <a:defRPr sz="3200" b="1">
                 <a:solidFill>
-                  <a:srgbClr val="C8302F"/>
+                  <a:srgbClr val="B02121"/>
                 </a:solidFill>
                 <a:latin typeface="Calibri"/>
               </a:defRPr>
@@ -11371,7 +11372,7 @@
             <a:avLst/>
           </a:prstGeom>
           <a:solidFill>
-            <a:srgbClr val="FBE7E6"/>
+            <a:srgbClr val="FCE4E4"/>
           </a:solidFill>
           <a:ln>
             <a:noFill/>
@@ -11414,7 +11415,7 @@
             <a:avLst/>
           </a:prstGeom>
           <a:solidFill>
-            <a:srgbClr val="C8302F"/>
+            <a:srgbClr val="B02121"/>
           </a:solidFill>
           <a:ln>
             <a:noFill/>
@@ -11467,7 +11468,7 @@
             <a:pPr algn="l">
               <a:defRPr sz="3000" b="1">
                 <a:solidFill>
-                  <a:srgbClr val="C8302F"/>
+                  <a:srgbClr val="B02121"/>
                 </a:solidFill>
                 <a:latin typeface="Calibri"/>
               </a:defRPr>
@@ -11529,7 +11530,7 @@
             <a:avLst/>
           </a:prstGeom>
           <a:solidFill>
-            <a:srgbClr val="FBE7E6"/>
+            <a:srgbClr val="FCE4E4"/>
           </a:solidFill>
           <a:ln>
             <a:noFill/>
@@ -11572,7 +11573,7 @@
             <a:avLst/>
           </a:prstGeom>
           <a:solidFill>
-            <a:srgbClr val="C8302F"/>
+            <a:srgbClr val="B02121"/>
           </a:solidFill>
           <a:ln>
             <a:noFill/>
@@ -11625,7 +11626,7 @@
             <a:pPr algn="l">
               <a:defRPr sz="3000" b="1">
                 <a:solidFill>
-                  <a:srgbClr val="C8302F"/>
+                  <a:srgbClr val="B02121"/>
                 </a:solidFill>
                 <a:latin typeface="Calibri"/>
               </a:defRPr>
@@ -11687,7 +11688,7 @@
             <a:avLst/>
           </a:prstGeom>
           <a:solidFill>
-            <a:srgbClr val="FBE7E6"/>
+            <a:srgbClr val="FCE4E4"/>
           </a:solidFill>
           <a:ln>
             <a:noFill/>
@@ -11730,7 +11731,7 @@
             <a:avLst/>
           </a:prstGeom>
           <a:solidFill>
-            <a:srgbClr val="C8302F"/>
+            <a:srgbClr val="B02121"/>
           </a:solidFill>
           <a:ln>
             <a:noFill/>
@@ -11783,7 +11784,7 @@
             <a:pPr algn="l">
               <a:defRPr sz="3000" b="1">
                 <a:solidFill>
-                  <a:srgbClr val="C8302F"/>
+                  <a:srgbClr val="B02121"/>
                 </a:solidFill>
                 <a:latin typeface="Calibri"/>
               </a:defRPr>
@@ -11826,6 +11827,2166 @@
             </a:pPr>
             <a:r>
               <a:t>G7 Asian still declining under IM — only subgroup not recovering</a:t>
+            </a:r>
+          </a:p>
+        </p:txBody>
+      </p:sp>
+    </p:spTree>
+  </p:cSld>
+  <p:clrMapOvr>
+    <a:masterClrMapping/>
+  </p:clrMapOvr>
+</p:sld>
+</file>
+
+<file path=ppt/slides/slide20.xml><?xml version="1.0" encoding="utf-8"?>
+<p:sld xmlns:a="http://schemas.openxmlformats.org/drawingml/2006/main" xmlns:p="http://schemas.openxmlformats.org/presentationml/2006/main" xmlns:r="http://schemas.openxmlformats.org/officeDocument/2006/relationships">
+  <p:cSld>
+    <p:bg>
+      <p:bgPr>
+        <a:solidFill>
+          <a:srgbClr val="EAEDF2"/>
+        </a:solidFill>
+        <a:effectLst/>
+      </p:bgPr>
+    </p:bg>
+    <p:spTree>
+      <p:nvGrpSpPr>
+        <p:cNvPr id="1" name=""/>
+        <p:cNvGrpSpPr/>
+        <p:nvPr/>
+      </p:nvGrpSpPr>
+      <p:grpSpPr/>
+      <p:sp>
+        <p:nvSpPr>
+          <p:cNvPr id="2" name="Rectangle 1"/>
+          <p:cNvSpPr/>
+          <p:nvPr/>
+        </p:nvSpPr>
+        <p:spPr>
+          <a:xfrm>
+            <a:off x="0" y="0"/>
+            <a:ext cx="12191695" cy="868680"/>
+          </a:xfrm>
+          <a:prstGeom prst="rect">
+            <a:avLst/>
+          </a:prstGeom>
+          <a:solidFill>
+            <a:srgbClr val="1F3A5F"/>
+          </a:solidFill>
+          <a:ln>
+            <a:noFill/>
+          </a:ln>
+        </p:spPr>
+        <p:style>
+          <a:lnRef idx="1">
+            <a:schemeClr val="accent1"/>
+          </a:lnRef>
+          <a:fillRef idx="3">
+            <a:schemeClr val="accent1"/>
+          </a:fillRef>
+          <a:effectRef idx="2">
+            <a:schemeClr val="accent1"/>
+          </a:effectRef>
+          <a:fontRef idx="minor">
+            <a:schemeClr val="lt1"/>
+          </a:fontRef>
+        </p:style>
+        <p:txBody>
+          <a:bodyPr rtlCol="0" anchor="ctr"/>
+          <a:lstStyle/>
+          <a:p>
+            <a:pPr algn="ctr"/>
+          </a:p>
+        </p:txBody>
+      </p:sp>
+      <p:sp>
+        <p:nvSpPr>
+          <p:cNvPr id="3" name="TextBox 2"/>
+          <p:cNvSpPr txBox="1"/>
+          <p:nvPr/>
+        </p:nvSpPr>
+        <p:spPr>
+          <a:xfrm>
+            <a:off x="457200" y="109728"/>
+            <a:ext cx="11247120" cy="457200"/>
+          </a:xfrm>
+          <a:prstGeom prst="rect">
+            <a:avLst/>
+          </a:prstGeom>
+          <a:noFill/>
+        </p:spPr>
+        <p:txBody>
+          <a:bodyPr wrap="square" anchor="t">
+            <a:spAutoFit/>
+          </a:bodyPr>
+          <a:lstStyle/>
+          <a:p>
+            <a:pPr algn="l">
+              <a:defRPr sz="2300" b="1">
+                <a:solidFill>
+                  <a:srgbClr val="FFFFFF"/>
+                </a:solidFill>
+                <a:latin typeface="Calibri"/>
+              </a:defRPr>
+            </a:pPr>
+            <a:r>
+              <a:t>Appendix -- Troy Slid from Top 2% to Top 4% Nationally in G6+G7 Math</a:t>
+            </a:r>
+          </a:p>
+        </p:txBody>
+      </p:sp>
+      <p:sp>
+        <p:nvSpPr>
+          <p:cNvPr id="4" name="TextBox 3"/>
+          <p:cNvSpPr txBox="1"/>
+          <p:nvPr/>
+        </p:nvSpPr>
+        <p:spPr>
+          <a:xfrm>
+            <a:off x="457200" y="475488"/>
+            <a:ext cx="11247120" cy="320040"/>
+          </a:xfrm>
+          <a:prstGeom prst="rect">
+            <a:avLst/>
+          </a:prstGeom>
+          <a:noFill/>
+        </p:spPr>
+        <p:txBody>
+          <a:bodyPr wrap="square" anchor="t">
+            <a:spAutoFit/>
+          </a:bodyPr>
+          <a:lstStyle/>
+          <a:p>
+            <a:pPr algn="l">
+              <a:defRPr sz="1200" b="0">
+                <a:solidFill>
+                  <a:srgbClr val="CCDDEE"/>
+                </a:solidFill>
+                <a:latin typeface="Calibri"/>
+              </a:defRPr>
+            </a:pPr>
+            <a:r>
+              <a:t>Year-by-year SEDA national ranking (all U.S. districts) + absolute level among 296 level-matched peers</a:t>
+            </a:r>
+          </a:p>
+        </p:txBody>
+      </p:sp>
+      <p:sp>
+        <p:nvSpPr>
+          <p:cNvPr id="5" name="Rectangle 4"/>
+          <p:cNvSpPr/>
+          <p:nvPr/>
+        </p:nvSpPr>
+        <p:spPr>
+          <a:xfrm>
+            <a:off x="0" y="6601968"/>
+            <a:ext cx="12191695" cy="256032"/>
+          </a:xfrm>
+          <a:prstGeom prst="rect">
+            <a:avLst/>
+          </a:prstGeom>
+          <a:solidFill>
+            <a:srgbClr val="1F3A5F"/>
+          </a:solidFill>
+          <a:ln>
+            <a:noFill/>
+          </a:ln>
+        </p:spPr>
+        <p:style>
+          <a:lnRef idx="1">
+            <a:schemeClr val="accent1"/>
+          </a:lnRef>
+          <a:fillRef idx="3">
+            <a:schemeClr val="accent1"/>
+          </a:fillRef>
+          <a:effectRef idx="2">
+            <a:schemeClr val="accent1"/>
+          </a:effectRef>
+          <a:fontRef idx="minor">
+            <a:schemeClr val="lt1"/>
+          </a:fontRef>
+        </p:style>
+        <p:txBody>
+          <a:bodyPr rtlCol="0" anchor="ctr"/>
+          <a:lstStyle/>
+          <a:p>
+            <a:pPr algn="ctr"/>
+          </a:p>
+        </p:txBody>
+      </p:sp>
+      <p:sp>
+        <p:nvSpPr>
+          <p:cNvPr id="6" name="TextBox 5"/>
+          <p:cNvSpPr txBox="1"/>
+          <p:nvPr/>
+        </p:nvSpPr>
+        <p:spPr>
+          <a:xfrm>
+            <a:off x="365760" y="6638544"/>
+            <a:ext cx="8229600" cy="201168"/>
+          </a:xfrm>
+          <a:prstGeom prst="rect">
+            <a:avLst/>
+          </a:prstGeom>
+          <a:noFill/>
+        </p:spPr>
+        <p:txBody>
+          <a:bodyPr wrap="square" anchor="t">
+            <a:spAutoFit/>
+          </a:bodyPr>
+          <a:lstStyle/>
+          <a:p>
+            <a:pPr algn="l">
+              <a:defRPr sz="800" b="0">
+                <a:solidFill>
+                  <a:srgbClr val="FFFFFF"/>
+                </a:solidFill>
+                <a:latin typeface="Calibri"/>
+              </a:defRPr>
+            </a:pPr>
+            <a:r>
+              <a:t>Troy SD G6-G7 Math — Executive Summary • github.com/akarpo/tsd-g6g7math-choice</a:t>
+            </a:r>
+          </a:p>
+        </p:txBody>
+      </p:sp>
+      <p:sp>
+        <p:nvSpPr>
+          <p:cNvPr id="7" name="TextBox 6"/>
+          <p:cNvSpPr txBox="1"/>
+          <p:nvPr/>
+        </p:nvSpPr>
+        <p:spPr>
+          <a:xfrm>
+            <a:off x="10515600" y="6638544"/>
+            <a:ext cx="1371600" cy="201168"/>
+          </a:xfrm>
+          <a:prstGeom prst="rect">
+            <a:avLst/>
+          </a:prstGeom>
+          <a:noFill/>
+        </p:spPr>
+        <p:txBody>
+          <a:bodyPr wrap="square" anchor="t">
+            <a:spAutoFit/>
+          </a:bodyPr>
+          <a:lstStyle/>
+          <a:p>
+            <a:pPr algn="r">
+              <a:defRPr sz="800" b="0">
+                <a:solidFill>
+                  <a:srgbClr val="FFFFFF"/>
+                </a:solidFill>
+                <a:latin typeface="Calibri"/>
+              </a:defRPr>
+            </a:pPr>
+            <a:r>
+              <a:t>20 / 20</a:t>
+            </a:r>
+          </a:p>
+        </p:txBody>
+      </p:sp>
+      <p:sp>
+        <p:nvSpPr>
+          <p:cNvPr id="8" name="Rectangle 7"/>
+          <p:cNvSpPr/>
+          <p:nvPr/>
+        </p:nvSpPr>
+        <p:spPr>
+          <a:xfrm>
+            <a:off x="274320" y="868680"/>
+            <a:ext cx="4754880" cy="4206240"/>
+          </a:xfrm>
+          <a:prstGeom prst="rect">
+            <a:avLst/>
+          </a:prstGeom>
+          <a:solidFill>
+            <a:srgbClr val="FCE4E4"/>
+          </a:solidFill>
+          <a:ln>
+            <a:noFill/>
+          </a:ln>
+        </p:spPr>
+        <p:style>
+          <a:lnRef idx="1">
+            <a:schemeClr val="accent1"/>
+          </a:lnRef>
+          <a:fillRef idx="3">
+            <a:schemeClr val="accent1"/>
+          </a:fillRef>
+          <a:effectRef idx="2">
+            <a:schemeClr val="accent1"/>
+          </a:effectRef>
+          <a:fontRef idx="minor">
+            <a:schemeClr val="lt1"/>
+          </a:fontRef>
+        </p:style>
+        <p:txBody>
+          <a:bodyPr rtlCol="0" anchor="ctr"/>
+          <a:lstStyle/>
+          <a:p>
+            <a:pPr algn="ctr"/>
+          </a:p>
+        </p:txBody>
+      </p:sp>
+      <p:sp>
+        <p:nvSpPr>
+          <p:cNvPr id="9" name="TextBox 8"/>
+          <p:cNvSpPr txBox="1"/>
+          <p:nvPr/>
+        </p:nvSpPr>
+        <p:spPr>
+          <a:xfrm>
+            <a:off x="457200" y="960120"/>
+            <a:ext cx="4389120" cy="320040"/>
+          </a:xfrm>
+          <a:prstGeom prst="rect">
+            <a:avLst/>
+          </a:prstGeom>
+          <a:noFill/>
+        </p:spPr>
+        <p:txBody>
+          <a:bodyPr wrap="square" anchor="t">
+            <a:spAutoFit/>
+          </a:bodyPr>
+          <a:lstStyle/>
+          <a:p>
+            <a:pPr algn="l">
+              <a:defRPr sz="1400" b="1">
+                <a:solidFill>
+                  <a:srgbClr val="B02121"/>
+                </a:solidFill>
+                <a:latin typeface="Calibri"/>
+              </a:defRPr>
+            </a:pPr>
+            <a:r>
+              <a:t>National G6+G7 Math ranking trajectory</a:t>
+            </a:r>
+          </a:p>
+        </p:txBody>
+      </p:sp>
+      <p:sp>
+        <p:nvSpPr>
+          <p:cNvPr id="10" name="TextBox 9"/>
+          <p:cNvSpPr txBox="1"/>
+          <p:nvPr/>
+        </p:nvSpPr>
+        <p:spPr>
+          <a:xfrm>
+            <a:off x="457200" y="1298448"/>
+            <a:ext cx="4389120" cy="228600"/>
+          </a:xfrm>
+          <a:prstGeom prst="rect">
+            <a:avLst/>
+          </a:prstGeom>
+          <a:noFill/>
+        </p:spPr>
+        <p:txBody>
+          <a:bodyPr wrap="square" anchor="t">
+            <a:spAutoFit/>
+          </a:bodyPr>
+          <a:lstStyle/>
+          <a:p>
+            <a:pPr algn="l">
+              <a:defRPr sz="1000" b="0">
+                <a:solidFill>
+                  <a:srgbClr val="707070"/>
+                </a:solidFill>
+                <a:latin typeface="Calibri"/>
+              </a:defRPr>
+            </a:pPr>
+            <a:r>
+              <a:t>SEDA 2025.1 cs scale -- all U.S. districts with G6+G7 math data</a:t>
+            </a:r>
+          </a:p>
+        </p:txBody>
+      </p:sp>
+      <p:sp>
+        <p:nvSpPr>
+          <p:cNvPr id="11" name="Rectangle 10"/>
+          <p:cNvSpPr/>
+          <p:nvPr/>
+        </p:nvSpPr>
+        <p:spPr>
+          <a:xfrm>
+            <a:off x="365760" y="1600200"/>
+            <a:ext cx="4572000" cy="274320"/>
+          </a:xfrm>
+          <a:prstGeom prst="rect">
+            <a:avLst/>
+          </a:prstGeom>
+          <a:solidFill>
+            <a:srgbClr val="B02121"/>
+          </a:solidFill>
+          <a:ln>
+            <a:noFill/>
+          </a:ln>
+        </p:spPr>
+        <p:style>
+          <a:lnRef idx="1">
+            <a:schemeClr val="accent1"/>
+          </a:lnRef>
+          <a:fillRef idx="3">
+            <a:schemeClr val="accent1"/>
+          </a:fillRef>
+          <a:effectRef idx="2">
+            <a:schemeClr val="accent1"/>
+          </a:effectRef>
+          <a:fontRef idx="minor">
+            <a:schemeClr val="lt1"/>
+          </a:fontRef>
+        </p:style>
+        <p:txBody>
+          <a:bodyPr rtlCol="0" anchor="ctr"/>
+          <a:lstStyle/>
+          <a:p>
+            <a:pPr algn="ctr"/>
+          </a:p>
+        </p:txBody>
+      </p:sp>
+      <p:sp>
+        <p:nvSpPr>
+          <p:cNvPr id="12" name="TextBox 11"/>
+          <p:cNvSpPr txBox="1"/>
+          <p:nvPr/>
+        </p:nvSpPr>
+        <p:spPr>
+          <a:xfrm>
+            <a:off x="457200" y="1636776"/>
+            <a:ext cx="868680" cy="228600"/>
+          </a:xfrm>
+          <a:prstGeom prst="rect">
+            <a:avLst/>
+          </a:prstGeom>
+          <a:noFill/>
+        </p:spPr>
+        <p:txBody>
+          <a:bodyPr wrap="square" anchor="t">
+            <a:spAutoFit/>
+          </a:bodyPr>
+          <a:lstStyle/>
+          <a:p>
+            <a:pPr algn="l">
+              <a:defRPr sz="1100" b="1">
+                <a:solidFill>
+                  <a:srgbClr val="FFFFFF"/>
+                </a:solidFill>
+                <a:latin typeface="Calibri"/>
+              </a:defRPr>
+            </a:pPr>
+            <a:r>
+              <a:t>Year</a:t>
+            </a:r>
+          </a:p>
+        </p:txBody>
+      </p:sp>
+      <p:sp>
+        <p:nvSpPr>
+          <p:cNvPr id="13" name="TextBox 12"/>
+          <p:cNvSpPr txBox="1"/>
+          <p:nvPr/>
+        </p:nvSpPr>
+        <p:spPr>
+          <a:xfrm>
+            <a:off x="1417320" y="1636776"/>
+            <a:ext cx="1005840" cy="228600"/>
+          </a:xfrm>
+          <a:prstGeom prst="rect">
+            <a:avLst/>
+          </a:prstGeom>
+          <a:noFill/>
+        </p:spPr>
+        <p:txBody>
+          <a:bodyPr wrap="square" anchor="t">
+            <a:spAutoFit/>
+          </a:bodyPr>
+          <a:lstStyle/>
+          <a:p>
+            <a:pPr algn="l">
+              <a:defRPr sz="1100" b="1">
+                <a:solidFill>
+                  <a:srgbClr val="FFFFFF"/>
+                </a:solidFill>
+                <a:latin typeface="Calibri"/>
+              </a:defRPr>
+            </a:pPr>
+            <a:r>
+              <a:t>Score</a:t>
+            </a:r>
+          </a:p>
+        </p:txBody>
+      </p:sp>
+      <p:sp>
+        <p:nvSpPr>
+          <p:cNvPr id="14" name="TextBox 13"/>
+          <p:cNvSpPr txBox="1"/>
+          <p:nvPr/>
+        </p:nvSpPr>
+        <p:spPr>
+          <a:xfrm>
+            <a:off x="2514600" y="1636776"/>
+            <a:ext cx="868680" cy="228600"/>
+          </a:xfrm>
+          <a:prstGeom prst="rect">
+            <a:avLst/>
+          </a:prstGeom>
+          <a:noFill/>
+        </p:spPr>
+        <p:txBody>
+          <a:bodyPr wrap="square" anchor="t">
+            <a:spAutoFit/>
+          </a:bodyPr>
+          <a:lstStyle/>
+          <a:p>
+            <a:pPr algn="l">
+              <a:defRPr sz="1100" b="1">
+                <a:solidFill>
+                  <a:srgbClr val="FFFFFF"/>
+                </a:solidFill>
+                <a:latin typeface="Calibri"/>
+              </a:defRPr>
+            </a:pPr>
+            <a:r>
+              <a:t>Rank</a:t>
+            </a:r>
+          </a:p>
+        </p:txBody>
+      </p:sp>
+      <p:sp>
+        <p:nvSpPr>
+          <p:cNvPr id="15" name="TextBox 14"/>
+          <p:cNvSpPr txBox="1"/>
+          <p:nvPr/>
+        </p:nvSpPr>
+        <p:spPr>
+          <a:xfrm>
+            <a:off x="3429000" y="1636776"/>
+            <a:ext cx="1280160" cy="228600"/>
+          </a:xfrm>
+          <a:prstGeom prst="rect">
+            <a:avLst/>
+          </a:prstGeom>
+          <a:noFill/>
+        </p:spPr>
+        <p:txBody>
+          <a:bodyPr wrap="square" anchor="t">
+            <a:spAutoFit/>
+          </a:bodyPr>
+          <a:lstStyle/>
+          <a:p>
+            <a:pPr algn="l">
+              <a:defRPr sz="1100" b="1">
+                <a:solidFill>
+                  <a:srgbClr val="FFFFFF"/>
+                </a:solidFill>
+                <a:latin typeface="Calibri"/>
+              </a:defRPr>
+            </a:pPr>
+            <a:r>
+              <a:t>Percentile</a:t>
+            </a:r>
+          </a:p>
+        </p:txBody>
+      </p:sp>
+      <p:sp>
+        <p:nvSpPr>
+          <p:cNvPr id="16" name="Rectangle 15"/>
+          <p:cNvSpPr/>
+          <p:nvPr/>
+        </p:nvSpPr>
+        <p:spPr>
+          <a:xfrm>
+            <a:off x="365760" y="1929384"/>
+            <a:ext cx="4572000" cy="365760"/>
+          </a:xfrm>
+          <a:prstGeom prst="rect">
+            <a:avLst/>
+          </a:prstGeom>
+          <a:solidFill>
+            <a:srgbClr val="E6F4E8"/>
+          </a:solidFill>
+          <a:ln>
+            <a:noFill/>
+          </a:ln>
+        </p:spPr>
+        <p:style>
+          <a:lnRef idx="1">
+            <a:schemeClr val="accent1"/>
+          </a:lnRef>
+          <a:fillRef idx="3">
+            <a:schemeClr val="accent1"/>
+          </a:fillRef>
+          <a:effectRef idx="2">
+            <a:schemeClr val="accent1"/>
+          </a:effectRef>
+          <a:fontRef idx="minor">
+            <a:schemeClr val="lt1"/>
+          </a:fontRef>
+        </p:style>
+        <p:txBody>
+          <a:bodyPr rtlCol="0" anchor="ctr"/>
+          <a:lstStyle/>
+          <a:p>
+            <a:pPr algn="ctr"/>
+          </a:p>
+        </p:txBody>
+      </p:sp>
+      <p:sp>
+        <p:nvSpPr>
+          <p:cNvPr id="17" name="TextBox 16"/>
+          <p:cNvSpPr txBox="1"/>
+          <p:nvPr/>
+        </p:nvSpPr>
+        <p:spPr>
+          <a:xfrm>
+            <a:off x="457200" y="1947672"/>
+            <a:ext cx="868680" cy="320040"/>
+          </a:xfrm>
+          <a:prstGeom prst="rect">
+            <a:avLst/>
+          </a:prstGeom>
+          <a:noFill/>
+        </p:spPr>
+        <p:txBody>
+          <a:bodyPr wrap="square" anchor="t">
+            <a:spAutoFit/>
+          </a:bodyPr>
+          <a:lstStyle/>
+          <a:p>
+            <a:pPr algn="l">
+              <a:defRPr sz="1400" b="1">
+                <a:solidFill>
+                  <a:srgbClr val="333333"/>
+                </a:solidFill>
+                <a:latin typeface="Calibri"/>
+              </a:defRPr>
+            </a:pPr>
+            <a:r>
+              <a:t>2019</a:t>
+            </a:r>
+          </a:p>
+        </p:txBody>
+      </p:sp>
+      <p:sp>
+        <p:nvSpPr>
+          <p:cNvPr id="18" name="TextBox 17"/>
+          <p:cNvSpPr txBox="1"/>
+          <p:nvPr/>
+        </p:nvSpPr>
+        <p:spPr>
+          <a:xfrm>
+            <a:off x="1417320" y="1947672"/>
+            <a:ext cx="1005840" cy="320040"/>
+          </a:xfrm>
+          <a:prstGeom prst="rect">
+            <a:avLst/>
+          </a:prstGeom>
+          <a:noFill/>
+        </p:spPr>
+        <p:txBody>
+          <a:bodyPr wrap="square" anchor="t">
+            <a:spAutoFit/>
+          </a:bodyPr>
+          <a:lstStyle/>
+          <a:p>
+            <a:pPr algn="l">
+              <a:defRPr sz="1400" b="0">
+                <a:solidFill>
+                  <a:srgbClr val="333333"/>
+                </a:solidFill>
+                <a:latin typeface="Consolas"/>
+              </a:defRPr>
+            </a:pPr>
+            <a:r>
+              <a:t>+0.952</a:t>
+            </a:r>
+          </a:p>
+        </p:txBody>
+      </p:sp>
+      <p:sp>
+        <p:nvSpPr>
+          <p:cNvPr id="19" name="TextBox 18"/>
+          <p:cNvSpPr txBox="1"/>
+          <p:nvPr/>
+        </p:nvSpPr>
+        <p:spPr>
+          <a:xfrm>
+            <a:off x="2514600" y="1947672"/>
+            <a:ext cx="868680" cy="320040"/>
+          </a:xfrm>
+          <a:prstGeom prst="rect">
+            <a:avLst/>
+          </a:prstGeom>
+          <a:noFill/>
+        </p:spPr>
+        <p:txBody>
+          <a:bodyPr wrap="square" anchor="t">
+            <a:spAutoFit/>
+          </a:bodyPr>
+          <a:lstStyle/>
+          <a:p>
+            <a:pPr algn="l">
+              <a:defRPr sz="1200" b="0">
+                <a:solidFill>
+                  <a:srgbClr val="333333"/>
+                </a:solidFill>
+                <a:latin typeface="Consolas"/>
+              </a:defRPr>
+            </a:pPr>
+            <a:r>
+              <a:t>173 / 8,751</a:t>
+            </a:r>
+          </a:p>
+        </p:txBody>
+      </p:sp>
+      <p:sp>
+        <p:nvSpPr>
+          <p:cNvPr id="20" name="TextBox 19"/>
+          <p:cNvSpPr txBox="1"/>
+          <p:nvPr/>
+        </p:nvSpPr>
+        <p:spPr>
+          <a:xfrm>
+            <a:off x="3429000" y="1947672"/>
+            <a:ext cx="1280160" cy="320040"/>
+          </a:xfrm>
+          <a:prstGeom prst="rect">
+            <a:avLst/>
+          </a:prstGeom>
+          <a:noFill/>
+        </p:spPr>
+        <p:txBody>
+          <a:bodyPr wrap="square" anchor="t">
+            <a:spAutoFit/>
+          </a:bodyPr>
+          <a:lstStyle/>
+          <a:p>
+            <a:pPr algn="l">
+              <a:defRPr sz="1300" b="1">
+                <a:solidFill>
+                  <a:srgbClr val="1F7A3D"/>
+                </a:solidFill>
+                <a:latin typeface="Calibri"/>
+              </a:defRPr>
+            </a:pPr>
+            <a:r>
+              <a:t>Top 2.0%</a:t>
+            </a:r>
+          </a:p>
+        </p:txBody>
+      </p:sp>
+      <p:sp>
+        <p:nvSpPr>
+          <p:cNvPr id="21" name="TextBox 20"/>
+          <p:cNvSpPr txBox="1"/>
+          <p:nvPr/>
+        </p:nvSpPr>
+        <p:spPr>
+          <a:xfrm>
+            <a:off x="457200" y="2331720"/>
+            <a:ext cx="868680" cy="320040"/>
+          </a:xfrm>
+          <a:prstGeom prst="rect">
+            <a:avLst/>
+          </a:prstGeom>
+          <a:noFill/>
+        </p:spPr>
+        <p:txBody>
+          <a:bodyPr wrap="square" anchor="t">
+            <a:spAutoFit/>
+          </a:bodyPr>
+          <a:lstStyle/>
+          <a:p>
+            <a:pPr algn="l">
+              <a:defRPr sz="1400" b="1">
+                <a:solidFill>
+                  <a:srgbClr val="333333"/>
+                </a:solidFill>
+                <a:latin typeface="Calibri"/>
+              </a:defRPr>
+            </a:pPr>
+            <a:r>
+              <a:t>2022</a:t>
+            </a:r>
+          </a:p>
+        </p:txBody>
+      </p:sp>
+      <p:sp>
+        <p:nvSpPr>
+          <p:cNvPr id="22" name="TextBox 21"/>
+          <p:cNvSpPr txBox="1"/>
+          <p:nvPr/>
+        </p:nvSpPr>
+        <p:spPr>
+          <a:xfrm>
+            <a:off x="1417320" y="2331720"/>
+            <a:ext cx="1005840" cy="320040"/>
+          </a:xfrm>
+          <a:prstGeom prst="rect">
+            <a:avLst/>
+          </a:prstGeom>
+          <a:noFill/>
+        </p:spPr>
+        <p:txBody>
+          <a:bodyPr wrap="square" anchor="t">
+            <a:spAutoFit/>
+          </a:bodyPr>
+          <a:lstStyle/>
+          <a:p>
+            <a:pPr algn="l">
+              <a:defRPr sz="1400" b="0">
+                <a:solidFill>
+                  <a:srgbClr val="333333"/>
+                </a:solidFill>
+                <a:latin typeface="Consolas"/>
+              </a:defRPr>
+            </a:pPr>
+            <a:r>
+              <a:t>+0.763</a:t>
+            </a:r>
+          </a:p>
+        </p:txBody>
+      </p:sp>
+      <p:sp>
+        <p:nvSpPr>
+          <p:cNvPr id="23" name="TextBox 22"/>
+          <p:cNvSpPr txBox="1"/>
+          <p:nvPr/>
+        </p:nvSpPr>
+        <p:spPr>
+          <a:xfrm>
+            <a:off x="2514600" y="2331720"/>
+            <a:ext cx="868680" cy="320040"/>
+          </a:xfrm>
+          <a:prstGeom prst="rect">
+            <a:avLst/>
+          </a:prstGeom>
+          <a:noFill/>
+        </p:spPr>
+        <p:txBody>
+          <a:bodyPr wrap="square" anchor="t">
+            <a:spAutoFit/>
+          </a:bodyPr>
+          <a:lstStyle/>
+          <a:p>
+            <a:pPr algn="l">
+              <a:defRPr sz="1200" b="0">
+                <a:solidFill>
+                  <a:srgbClr val="333333"/>
+                </a:solidFill>
+                <a:latin typeface="Consolas"/>
+              </a:defRPr>
+            </a:pPr>
+            <a:r>
+              <a:t>229 / 8,215</a:t>
+            </a:r>
+          </a:p>
+        </p:txBody>
+      </p:sp>
+      <p:sp>
+        <p:nvSpPr>
+          <p:cNvPr id="24" name="TextBox 23"/>
+          <p:cNvSpPr txBox="1"/>
+          <p:nvPr/>
+        </p:nvSpPr>
+        <p:spPr>
+          <a:xfrm>
+            <a:off x="3429000" y="2331720"/>
+            <a:ext cx="1280160" cy="320040"/>
+          </a:xfrm>
+          <a:prstGeom prst="rect">
+            <a:avLst/>
+          </a:prstGeom>
+          <a:noFill/>
+        </p:spPr>
+        <p:txBody>
+          <a:bodyPr wrap="square" anchor="t">
+            <a:spAutoFit/>
+          </a:bodyPr>
+          <a:lstStyle/>
+          <a:p>
+            <a:pPr algn="l">
+              <a:defRPr sz="1300" b="1">
+                <a:solidFill>
+                  <a:srgbClr val="333333"/>
+                </a:solidFill>
+                <a:latin typeface="Calibri"/>
+              </a:defRPr>
+            </a:pPr>
+            <a:r>
+              <a:t>Top 2.8%</a:t>
+            </a:r>
+          </a:p>
+        </p:txBody>
+      </p:sp>
+      <p:sp>
+        <p:nvSpPr>
+          <p:cNvPr id="25" name="TextBox 24"/>
+          <p:cNvSpPr txBox="1"/>
+          <p:nvPr/>
+        </p:nvSpPr>
+        <p:spPr>
+          <a:xfrm>
+            <a:off x="457200" y="2715768"/>
+            <a:ext cx="868680" cy="320040"/>
+          </a:xfrm>
+          <a:prstGeom prst="rect">
+            <a:avLst/>
+          </a:prstGeom>
+          <a:noFill/>
+        </p:spPr>
+        <p:txBody>
+          <a:bodyPr wrap="square" anchor="t">
+            <a:spAutoFit/>
+          </a:bodyPr>
+          <a:lstStyle/>
+          <a:p>
+            <a:pPr algn="l">
+              <a:defRPr sz="1400" b="1">
+                <a:solidFill>
+                  <a:srgbClr val="B02121"/>
+                </a:solidFill>
+                <a:latin typeface="Calibri"/>
+              </a:defRPr>
+            </a:pPr>
+            <a:r>
+              <a:t>2023</a:t>
+            </a:r>
+          </a:p>
+        </p:txBody>
+      </p:sp>
+      <p:sp>
+        <p:nvSpPr>
+          <p:cNvPr id="26" name="TextBox 25"/>
+          <p:cNvSpPr txBox="1"/>
+          <p:nvPr/>
+        </p:nvSpPr>
+        <p:spPr>
+          <a:xfrm>
+            <a:off x="1417320" y="2715768"/>
+            <a:ext cx="1005840" cy="320040"/>
+          </a:xfrm>
+          <a:prstGeom prst="rect">
+            <a:avLst/>
+          </a:prstGeom>
+          <a:noFill/>
+        </p:spPr>
+        <p:txBody>
+          <a:bodyPr wrap="square" anchor="t">
+            <a:spAutoFit/>
+          </a:bodyPr>
+          <a:lstStyle/>
+          <a:p>
+            <a:pPr algn="l">
+              <a:defRPr sz="1400" b="0">
+                <a:solidFill>
+                  <a:srgbClr val="B02121"/>
+                </a:solidFill>
+                <a:latin typeface="Consolas"/>
+              </a:defRPr>
+            </a:pPr>
+            <a:r>
+              <a:t>+0.713</a:t>
+            </a:r>
+          </a:p>
+        </p:txBody>
+      </p:sp>
+      <p:sp>
+        <p:nvSpPr>
+          <p:cNvPr id="27" name="TextBox 26"/>
+          <p:cNvSpPr txBox="1"/>
+          <p:nvPr/>
+        </p:nvSpPr>
+        <p:spPr>
+          <a:xfrm>
+            <a:off x="2514600" y="2715768"/>
+            <a:ext cx="868680" cy="320040"/>
+          </a:xfrm>
+          <a:prstGeom prst="rect">
+            <a:avLst/>
+          </a:prstGeom>
+          <a:noFill/>
+        </p:spPr>
+        <p:txBody>
+          <a:bodyPr wrap="square" anchor="t">
+            <a:spAutoFit/>
+          </a:bodyPr>
+          <a:lstStyle/>
+          <a:p>
+            <a:pPr algn="l">
+              <a:defRPr sz="1200" b="0">
+                <a:solidFill>
+                  <a:srgbClr val="B02121"/>
+                </a:solidFill>
+                <a:latin typeface="Consolas"/>
+              </a:defRPr>
+            </a:pPr>
+            <a:r>
+              <a:t>269 / 7,190</a:t>
+            </a:r>
+          </a:p>
+        </p:txBody>
+      </p:sp>
+      <p:sp>
+        <p:nvSpPr>
+          <p:cNvPr id="28" name="TextBox 27"/>
+          <p:cNvSpPr txBox="1"/>
+          <p:nvPr/>
+        </p:nvSpPr>
+        <p:spPr>
+          <a:xfrm>
+            <a:off x="3429000" y="2715768"/>
+            <a:ext cx="1280160" cy="320040"/>
+          </a:xfrm>
+          <a:prstGeom prst="rect">
+            <a:avLst/>
+          </a:prstGeom>
+          <a:noFill/>
+        </p:spPr>
+        <p:txBody>
+          <a:bodyPr wrap="square" anchor="t">
+            <a:spAutoFit/>
+          </a:bodyPr>
+          <a:lstStyle/>
+          <a:p>
+            <a:pPr algn="l">
+              <a:defRPr sz="1300" b="1">
+                <a:solidFill>
+                  <a:srgbClr val="B02121"/>
+                </a:solidFill>
+                <a:latin typeface="Calibri"/>
+              </a:defRPr>
+            </a:pPr>
+            <a:r>
+              <a:t>Top 3.7%</a:t>
+            </a:r>
+          </a:p>
+        </p:txBody>
+      </p:sp>
+      <p:sp>
+        <p:nvSpPr>
+          <p:cNvPr id="29" name="TextBox 28"/>
+          <p:cNvSpPr txBox="1"/>
+          <p:nvPr/>
+        </p:nvSpPr>
+        <p:spPr>
+          <a:xfrm>
+            <a:off x="457200" y="3099816"/>
+            <a:ext cx="868680" cy="320040"/>
+          </a:xfrm>
+          <a:prstGeom prst="rect">
+            <a:avLst/>
+          </a:prstGeom>
+          <a:noFill/>
+        </p:spPr>
+        <p:txBody>
+          <a:bodyPr wrap="square" anchor="t">
+            <a:spAutoFit/>
+          </a:bodyPr>
+          <a:lstStyle/>
+          <a:p>
+            <a:pPr algn="l">
+              <a:defRPr sz="1400" b="1">
+                <a:solidFill>
+                  <a:srgbClr val="B02121"/>
+                </a:solidFill>
+                <a:latin typeface="Calibri"/>
+              </a:defRPr>
+            </a:pPr>
+            <a:r>
+              <a:t>2024</a:t>
+            </a:r>
+          </a:p>
+        </p:txBody>
+      </p:sp>
+      <p:sp>
+        <p:nvSpPr>
+          <p:cNvPr id="30" name="TextBox 29"/>
+          <p:cNvSpPr txBox="1"/>
+          <p:nvPr/>
+        </p:nvSpPr>
+        <p:spPr>
+          <a:xfrm>
+            <a:off x="1417320" y="3099816"/>
+            <a:ext cx="1005840" cy="320040"/>
+          </a:xfrm>
+          <a:prstGeom prst="rect">
+            <a:avLst/>
+          </a:prstGeom>
+          <a:noFill/>
+        </p:spPr>
+        <p:txBody>
+          <a:bodyPr wrap="square" anchor="t">
+            <a:spAutoFit/>
+          </a:bodyPr>
+          <a:lstStyle/>
+          <a:p>
+            <a:pPr algn="l">
+              <a:defRPr sz="1400" b="0">
+                <a:solidFill>
+                  <a:srgbClr val="B02121"/>
+                </a:solidFill>
+                <a:latin typeface="Consolas"/>
+              </a:defRPr>
+            </a:pPr>
+            <a:r>
+              <a:t>+0.734</a:t>
+            </a:r>
+          </a:p>
+        </p:txBody>
+      </p:sp>
+      <p:sp>
+        <p:nvSpPr>
+          <p:cNvPr id="31" name="TextBox 30"/>
+          <p:cNvSpPr txBox="1"/>
+          <p:nvPr/>
+        </p:nvSpPr>
+        <p:spPr>
+          <a:xfrm>
+            <a:off x="2514600" y="3099816"/>
+            <a:ext cx="868680" cy="320040"/>
+          </a:xfrm>
+          <a:prstGeom prst="rect">
+            <a:avLst/>
+          </a:prstGeom>
+          <a:noFill/>
+        </p:spPr>
+        <p:txBody>
+          <a:bodyPr wrap="square" anchor="t">
+            <a:spAutoFit/>
+          </a:bodyPr>
+          <a:lstStyle/>
+          <a:p>
+            <a:pPr algn="l">
+              <a:defRPr sz="1200" b="0">
+                <a:solidFill>
+                  <a:srgbClr val="B02121"/>
+                </a:solidFill>
+                <a:latin typeface="Consolas"/>
+              </a:defRPr>
+            </a:pPr>
+            <a:r>
+              <a:t>294 / 6,995</a:t>
+            </a:r>
+          </a:p>
+        </p:txBody>
+      </p:sp>
+      <p:sp>
+        <p:nvSpPr>
+          <p:cNvPr id="32" name="TextBox 31"/>
+          <p:cNvSpPr txBox="1"/>
+          <p:nvPr/>
+        </p:nvSpPr>
+        <p:spPr>
+          <a:xfrm>
+            <a:off x="3429000" y="3099816"/>
+            <a:ext cx="1280160" cy="320040"/>
+          </a:xfrm>
+          <a:prstGeom prst="rect">
+            <a:avLst/>
+          </a:prstGeom>
+          <a:noFill/>
+        </p:spPr>
+        <p:txBody>
+          <a:bodyPr wrap="square" anchor="t">
+            <a:spAutoFit/>
+          </a:bodyPr>
+          <a:lstStyle/>
+          <a:p>
+            <a:pPr algn="l">
+              <a:defRPr sz="1300" b="1">
+                <a:solidFill>
+                  <a:srgbClr val="B02121"/>
+                </a:solidFill>
+                <a:latin typeface="Calibri"/>
+              </a:defRPr>
+            </a:pPr>
+            <a:r>
+              <a:t>Top 4.2%</a:t>
+            </a:r>
+          </a:p>
+        </p:txBody>
+      </p:sp>
+      <p:sp>
+        <p:nvSpPr>
+          <p:cNvPr id="33" name="TextBox 32"/>
+          <p:cNvSpPr txBox="1"/>
+          <p:nvPr/>
+        </p:nvSpPr>
+        <p:spPr>
+          <a:xfrm>
+            <a:off x="457200" y="3483864"/>
+            <a:ext cx="868680" cy="320040"/>
+          </a:xfrm>
+          <a:prstGeom prst="rect">
+            <a:avLst/>
+          </a:prstGeom>
+          <a:noFill/>
+        </p:spPr>
+        <p:txBody>
+          <a:bodyPr wrap="square" anchor="t">
+            <a:spAutoFit/>
+          </a:bodyPr>
+          <a:lstStyle/>
+          <a:p>
+            <a:pPr algn="l">
+              <a:defRPr sz="1400" b="1">
+                <a:solidFill>
+                  <a:srgbClr val="B02121"/>
+                </a:solidFill>
+                <a:latin typeface="Calibri"/>
+              </a:defRPr>
+            </a:pPr>
+            <a:r>
+              <a:t>2025</a:t>
+            </a:r>
+          </a:p>
+        </p:txBody>
+      </p:sp>
+      <p:sp>
+        <p:nvSpPr>
+          <p:cNvPr id="34" name="TextBox 33"/>
+          <p:cNvSpPr txBox="1"/>
+          <p:nvPr/>
+        </p:nvSpPr>
+        <p:spPr>
+          <a:xfrm>
+            <a:off x="1417320" y="3483864"/>
+            <a:ext cx="1005840" cy="320040"/>
+          </a:xfrm>
+          <a:prstGeom prst="rect">
+            <a:avLst/>
+          </a:prstGeom>
+          <a:noFill/>
+        </p:spPr>
+        <p:txBody>
+          <a:bodyPr wrap="square" anchor="t">
+            <a:spAutoFit/>
+          </a:bodyPr>
+          <a:lstStyle/>
+          <a:p>
+            <a:pPr algn="l">
+              <a:defRPr sz="1400" b="0">
+                <a:solidFill>
+                  <a:srgbClr val="B02121"/>
+                </a:solidFill>
+                <a:latin typeface="Consolas"/>
+              </a:defRPr>
+            </a:pPr>
+            <a:r>
+              <a:t>+0.790</a:t>
+            </a:r>
+          </a:p>
+        </p:txBody>
+      </p:sp>
+      <p:sp>
+        <p:nvSpPr>
+          <p:cNvPr id="35" name="TextBox 34"/>
+          <p:cNvSpPr txBox="1"/>
+          <p:nvPr/>
+        </p:nvSpPr>
+        <p:spPr>
+          <a:xfrm>
+            <a:off x="2514600" y="3483864"/>
+            <a:ext cx="868680" cy="320040"/>
+          </a:xfrm>
+          <a:prstGeom prst="rect">
+            <a:avLst/>
+          </a:prstGeom>
+          <a:noFill/>
+        </p:spPr>
+        <p:txBody>
+          <a:bodyPr wrap="square" anchor="t">
+            <a:spAutoFit/>
+          </a:bodyPr>
+          <a:lstStyle/>
+          <a:p>
+            <a:pPr algn="l">
+              <a:defRPr sz="1200" b="0">
+                <a:solidFill>
+                  <a:srgbClr val="B02121"/>
+                </a:solidFill>
+                <a:latin typeface="Consolas"/>
+              </a:defRPr>
+            </a:pPr>
+            <a:r>
+              <a:t>240 / 5,896</a:t>
+            </a:r>
+          </a:p>
+        </p:txBody>
+      </p:sp>
+      <p:sp>
+        <p:nvSpPr>
+          <p:cNvPr id="36" name="TextBox 35"/>
+          <p:cNvSpPr txBox="1"/>
+          <p:nvPr/>
+        </p:nvSpPr>
+        <p:spPr>
+          <a:xfrm>
+            <a:off x="3429000" y="3483864"/>
+            <a:ext cx="1280160" cy="320040"/>
+          </a:xfrm>
+          <a:prstGeom prst="rect">
+            <a:avLst/>
+          </a:prstGeom>
+          <a:noFill/>
+        </p:spPr>
+        <p:txBody>
+          <a:bodyPr wrap="square" anchor="t">
+            <a:spAutoFit/>
+          </a:bodyPr>
+          <a:lstStyle/>
+          <a:p>
+            <a:pPr algn="l">
+              <a:defRPr sz="1300" b="1">
+                <a:solidFill>
+                  <a:srgbClr val="B02121"/>
+                </a:solidFill>
+                <a:latin typeface="Calibri"/>
+              </a:defRPr>
+            </a:pPr>
+            <a:r>
+              <a:t>Top 4.1%</a:t>
+            </a:r>
+          </a:p>
+        </p:txBody>
+      </p:sp>
+      <p:sp>
+        <p:nvSpPr>
+          <p:cNvPr id="37" name="TextBox 36"/>
+          <p:cNvSpPr txBox="1"/>
+          <p:nvPr/>
+        </p:nvSpPr>
+        <p:spPr>
+          <a:xfrm>
+            <a:off x="457200" y="3858768"/>
+            <a:ext cx="4389120" cy="274320"/>
+          </a:xfrm>
+          <a:prstGeom prst="rect">
+            <a:avLst/>
+          </a:prstGeom>
+          <a:noFill/>
+        </p:spPr>
+        <p:txBody>
+          <a:bodyPr wrap="square" anchor="t">
+            <a:spAutoFit/>
+          </a:bodyPr>
+          <a:lstStyle/>
+          <a:p>
+            <a:pPr algn="l">
+              <a:defRPr sz="1600" b="1">
+                <a:solidFill>
+                  <a:srgbClr val="B02121"/>
+                </a:solidFill>
+                <a:latin typeface="Calibri"/>
+              </a:defRPr>
+            </a:pPr>
+            <a:r>
+              <a:t>Dropped ~70 national places since 2019</a:t>
+            </a:r>
+          </a:p>
+        </p:txBody>
+      </p:sp>
+      <p:sp>
+        <p:nvSpPr>
+          <p:cNvPr id="38" name="TextBox 37"/>
+          <p:cNvSpPr txBox="1"/>
+          <p:nvPr/>
+        </p:nvSpPr>
+        <p:spPr>
+          <a:xfrm>
+            <a:off x="457200" y="4187952"/>
+            <a:ext cx="4389120" cy="777240"/>
+          </a:xfrm>
+          <a:prstGeom prst="rect">
+            <a:avLst/>
+          </a:prstGeom>
+          <a:noFill/>
+        </p:spPr>
+        <p:txBody>
+          <a:bodyPr wrap="square" anchor="t">
+            <a:spAutoFit/>
+          </a:bodyPr>
+          <a:lstStyle/>
+          <a:p>
+            <a:pPr algn="l">
+              <a:defRPr sz="1100" b="0">
+                <a:solidFill>
+                  <a:srgbClr val="333333"/>
+                </a:solidFill>
+                <a:latin typeface="Calibri"/>
+              </a:defRPr>
+            </a:pPr>
+            <a:r>
+              <a:t>Troy went from top 2% nationally to top 4%.</a:t>
+            </a:r>
+            <a:br/>
+            <a:r>
+              <a:t>Score declined -0.162 grade levels.</a:t>
+            </a:r>
+            <a:br/>
+            <a:r>
+              <a:t>2025 rank ticks up as score partially recovered.</a:t>
+            </a:r>
+          </a:p>
+        </p:txBody>
+      </p:sp>
+      <p:pic>
+        <p:nvPicPr>
+          <p:cNvPr id="39" name="Picture 38" descr="chart_seda_scatter_math.png"/>
+          <p:cNvPicPr>
+            <a:picLocks noChangeAspect="1"/>
+          </p:cNvPicPr>
+          <p:nvPr/>
+        </p:nvPicPr>
+        <p:blipFill>
+          <a:blip r:embed="rId2"/>
+          <a:stretch>
+            <a:fillRect/>
+          </a:stretch>
+        </p:blipFill>
+        <p:spPr>
+          <a:xfrm>
+            <a:off x="5212080" y="868680"/>
+            <a:ext cx="6675120" cy="4206240"/>
+          </a:xfrm>
+          <a:prstGeom prst="rect">
+            <a:avLst/>
+          </a:prstGeom>
+        </p:spPr>
+      </p:pic>
+      <p:sp>
+        <p:nvSpPr>
+          <p:cNvPr id="40" name="Rectangle 39"/>
+          <p:cNvSpPr/>
+          <p:nvPr/>
+        </p:nvSpPr>
+        <p:spPr>
+          <a:xfrm>
+            <a:off x="274320" y="5166360"/>
+            <a:ext cx="11612880" cy="1234440"/>
+          </a:xfrm>
+          <a:prstGeom prst="rect">
+            <a:avLst/>
+          </a:prstGeom>
+          <a:solidFill>
+            <a:srgbClr val="EEEEEE"/>
+          </a:solidFill>
+          <a:ln>
+            <a:noFill/>
+          </a:ln>
+        </p:spPr>
+        <p:style>
+          <a:lnRef idx="1">
+            <a:schemeClr val="accent1"/>
+          </a:lnRef>
+          <a:fillRef idx="3">
+            <a:schemeClr val="accent1"/>
+          </a:fillRef>
+          <a:effectRef idx="2">
+            <a:schemeClr val="accent1"/>
+          </a:effectRef>
+          <a:fontRef idx="minor">
+            <a:schemeClr val="lt1"/>
+          </a:fontRef>
+        </p:style>
+        <p:txBody>
+          <a:bodyPr rtlCol="0" anchor="ctr"/>
+          <a:lstStyle/>
+          <a:p>
+            <a:pPr algn="ctr"/>
+          </a:p>
+        </p:txBody>
+      </p:sp>
+      <p:sp>
+        <p:nvSpPr>
+          <p:cNvPr id="41" name="TextBox 40"/>
+          <p:cNvSpPr txBox="1"/>
+          <p:nvPr/>
+        </p:nvSpPr>
+        <p:spPr>
+          <a:xfrm>
+            <a:off x="457200" y="5212080"/>
+            <a:ext cx="4572000" cy="228600"/>
+          </a:xfrm>
+          <a:prstGeom prst="rect">
+            <a:avLst/>
+          </a:prstGeom>
+          <a:noFill/>
+        </p:spPr>
+        <p:txBody>
+          <a:bodyPr wrap="square" anchor="t">
+            <a:spAutoFit/>
+          </a:bodyPr>
+          <a:lstStyle/>
+          <a:p>
+            <a:pPr algn="l">
+              <a:defRPr sz="1100" b="1">
+                <a:solidFill>
+                  <a:srgbClr val="1F3A5F"/>
+                </a:solidFill>
+                <a:latin typeface="Calibri"/>
+              </a:defRPr>
+            </a:pPr>
+            <a:r>
+              <a:t>Among 296 level-matched peers</a:t>
+            </a:r>
+          </a:p>
+        </p:txBody>
+      </p:sp>
+      <p:sp>
+        <p:nvSpPr>
+          <p:cNvPr id="42" name="TextBox 41"/>
+          <p:cNvSpPr txBox="1"/>
+          <p:nvPr/>
+        </p:nvSpPr>
+        <p:spPr>
+          <a:xfrm>
+            <a:off x="457200" y="5440680"/>
+            <a:ext cx="4572000" cy="822960"/>
+          </a:xfrm>
+          <a:prstGeom prst="rect">
+            <a:avLst/>
+          </a:prstGeom>
+          <a:noFill/>
+        </p:spPr>
+        <p:txBody>
+          <a:bodyPr wrap="square" anchor="t">
+            <a:spAutoFit/>
+          </a:bodyPr>
+          <a:lstStyle/>
+          <a:p>
+            <a:pPr algn="l">
+              <a:defRPr sz="1100" b="0">
+                <a:solidFill>
+                  <a:srgbClr val="333333"/>
+                </a:solidFill>
+                <a:latin typeface="Consolas"/>
+              </a:defRPr>
+            </a:pPr>
+            <a:r>
+              <a:t>Pre-COVID rank:  76 / 296  (top quarter)</a:t>
+            </a:r>
+            <a:br/>
+            <a:r>
+              <a:t>Post-COVID rank: 135 / 296  (bottom 55%)</a:t>
+            </a:r>
+            <a:br/>
+            <a:r>
+              <a:t>70 districts leapfrogged Troy</a:t>
+            </a:r>
+          </a:p>
+        </p:txBody>
+      </p:sp>
+      <p:sp>
+        <p:nvSpPr>
+          <p:cNvPr id="43" name="TextBox 42"/>
+          <p:cNvSpPr txBox="1"/>
+          <p:nvPr/>
+        </p:nvSpPr>
+        <p:spPr>
+          <a:xfrm>
+            <a:off x="5212080" y="5212080"/>
+            <a:ext cx="6400800" cy="228600"/>
+          </a:xfrm>
+          <a:prstGeom prst="rect">
+            <a:avLst/>
+          </a:prstGeom>
+          <a:noFill/>
+        </p:spPr>
+        <p:txBody>
+          <a:bodyPr wrap="square" anchor="t">
+            <a:spAutoFit/>
+          </a:bodyPr>
+          <a:lstStyle/>
+          <a:p>
+            <a:pPr algn="l">
+              <a:defRPr sz="1100" b="1">
+                <a:solidFill>
+                  <a:srgbClr val="1F3A5F"/>
+                </a:solidFill>
+                <a:latin typeface="Calibri"/>
+              </a:defRPr>
+            </a:pPr>
+            <a:r>
+              <a:t>Michigan affluent peers -- score delta (2019 to 2025)</a:t>
+            </a:r>
+          </a:p>
+        </p:txBody>
+      </p:sp>
+      <p:sp>
+        <p:nvSpPr>
+          <p:cNvPr id="44" name="TextBox 43"/>
+          <p:cNvSpPr txBox="1"/>
+          <p:nvPr/>
+        </p:nvSpPr>
+        <p:spPr>
+          <a:xfrm>
+            <a:off x="5212080" y="5468112"/>
+            <a:ext cx="960120" cy="274320"/>
+          </a:xfrm>
+          <a:prstGeom prst="rect">
+            <a:avLst/>
+          </a:prstGeom>
+          <a:noFill/>
+        </p:spPr>
+        <p:txBody>
+          <a:bodyPr wrap="square" anchor="t">
+            <a:spAutoFit/>
+          </a:bodyPr>
+          <a:lstStyle/>
+          <a:p>
+            <a:pPr algn="l">
+              <a:defRPr sz="900" b="0">
+                <a:solidFill>
+                  <a:srgbClr val="333333"/>
+                </a:solidFill>
+                <a:latin typeface="Calibri"/>
+              </a:defRPr>
+            </a:pPr>
+            <a:r>
+              <a:t>Birmingham</a:t>
+            </a:r>
+          </a:p>
+        </p:txBody>
+      </p:sp>
+      <p:sp>
+        <p:nvSpPr>
+          <p:cNvPr id="45" name="TextBox 44"/>
+          <p:cNvSpPr txBox="1"/>
+          <p:nvPr/>
+        </p:nvSpPr>
+        <p:spPr>
+          <a:xfrm>
+            <a:off x="6172200" y="5468112"/>
+            <a:ext cx="594360" cy="274320"/>
+          </a:xfrm>
+          <a:prstGeom prst="rect">
+            <a:avLst/>
+          </a:prstGeom>
+          <a:noFill/>
+        </p:spPr>
+        <p:txBody>
+          <a:bodyPr wrap="square" anchor="t">
+            <a:spAutoFit/>
+          </a:bodyPr>
+          <a:lstStyle/>
+          <a:p>
+            <a:pPr algn="l">
+              <a:defRPr sz="900" b="1">
+                <a:solidFill>
+                  <a:srgbClr val="1F7A3D"/>
+                </a:solidFill>
+                <a:latin typeface="Calibri"/>
+              </a:defRPr>
+            </a:pPr>
+            <a:r>
+              <a:t>+0.131</a:t>
+            </a:r>
+          </a:p>
+        </p:txBody>
+      </p:sp>
+      <p:sp>
+        <p:nvSpPr>
+          <p:cNvPr id="46" name="TextBox 45"/>
+          <p:cNvSpPr txBox="1"/>
+          <p:nvPr/>
+        </p:nvSpPr>
+        <p:spPr>
+          <a:xfrm>
+            <a:off x="6812280" y="5468112"/>
+            <a:ext cx="960120" cy="274320"/>
+          </a:xfrm>
+          <a:prstGeom prst="rect">
+            <a:avLst/>
+          </a:prstGeom>
+          <a:noFill/>
+        </p:spPr>
+        <p:txBody>
+          <a:bodyPr wrap="square" anchor="t">
+            <a:spAutoFit/>
+          </a:bodyPr>
+          <a:lstStyle/>
+          <a:p>
+            <a:pPr algn="l">
+              <a:defRPr sz="900" b="0">
+                <a:solidFill>
+                  <a:srgbClr val="333333"/>
+                </a:solidFill>
+                <a:latin typeface="Calibri"/>
+              </a:defRPr>
+            </a:pPr>
+            <a:r>
+              <a:t>Northville</a:t>
+            </a:r>
+          </a:p>
+        </p:txBody>
+      </p:sp>
+      <p:sp>
+        <p:nvSpPr>
+          <p:cNvPr id="47" name="TextBox 46"/>
+          <p:cNvSpPr txBox="1"/>
+          <p:nvPr/>
+        </p:nvSpPr>
+        <p:spPr>
+          <a:xfrm>
+            <a:off x="7772400" y="5468112"/>
+            <a:ext cx="594360" cy="274320"/>
+          </a:xfrm>
+          <a:prstGeom prst="rect">
+            <a:avLst/>
+          </a:prstGeom>
+          <a:noFill/>
+        </p:spPr>
+        <p:txBody>
+          <a:bodyPr wrap="square" anchor="t">
+            <a:spAutoFit/>
+          </a:bodyPr>
+          <a:lstStyle/>
+          <a:p>
+            <a:pPr algn="l">
+              <a:defRPr sz="900" b="1">
+                <a:solidFill>
+                  <a:srgbClr val="1F7A3D"/>
+                </a:solidFill>
+                <a:latin typeface="Calibri"/>
+              </a:defRPr>
+            </a:pPr>
+            <a:r>
+              <a:t>+0.087</a:t>
+            </a:r>
+          </a:p>
+        </p:txBody>
+      </p:sp>
+      <p:sp>
+        <p:nvSpPr>
+          <p:cNvPr id="48" name="TextBox 47"/>
+          <p:cNvSpPr txBox="1"/>
+          <p:nvPr/>
+        </p:nvSpPr>
+        <p:spPr>
+          <a:xfrm>
+            <a:off x="8412480" y="5468112"/>
+            <a:ext cx="960120" cy="274320"/>
+          </a:xfrm>
+          <a:prstGeom prst="rect">
+            <a:avLst/>
+          </a:prstGeom>
+          <a:noFill/>
+        </p:spPr>
+        <p:txBody>
+          <a:bodyPr wrap="square" anchor="t">
+            <a:spAutoFit/>
+          </a:bodyPr>
+          <a:lstStyle/>
+          <a:p>
+            <a:pPr algn="l">
+              <a:defRPr sz="900" b="0">
+                <a:solidFill>
+                  <a:srgbClr val="333333"/>
+                </a:solidFill>
+                <a:latin typeface="Calibri"/>
+              </a:defRPr>
+            </a:pPr>
+            <a:r>
+              <a:t>Bloomfield Hills</a:t>
+            </a:r>
+          </a:p>
+        </p:txBody>
+      </p:sp>
+      <p:sp>
+        <p:nvSpPr>
+          <p:cNvPr id="49" name="TextBox 48"/>
+          <p:cNvSpPr txBox="1"/>
+          <p:nvPr/>
+        </p:nvSpPr>
+        <p:spPr>
+          <a:xfrm>
+            <a:off x="9372600" y="5468112"/>
+            <a:ext cx="594360" cy="274320"/>
+          </a:xfrm>
+          <a:prstGeom prst="rect">
+            <a:avLst/>
+          </a:prstGeom>
+          <a:noFill/>
+        </p:spPr>
+        <p:txBody>
+          <a:bodyPr wrap="square" anchor="t">
+            <a:spAutoFit/>
+          </a:bodyPr>
+          <a:lstStyle/>
+          <a:p>
+            <a:pPr algn="l">
+              <a:defRPr sz="900" b="1">
+                <a:solidFill>
+                  <a:srgbClr val="1F7A3D"/>
+                </a:solidFill>
+                <a:latin typeface="Calibri"/>
+              </a:defRPr>
+            </a:pPr>
+            <a:r>
+              <a:t>+0.085</a:t>
+            </a:r>
+          </a:p>
+        </p:txBody>
+      </p:sp>
+      <p:sp>
+        <p:nvSpPr>
+          <p:cNvPr id="50" name="TextBox 49"/>
+          <p:cNvSpPr txBox="1"/>
+          <p:nvPr/>
+        </p:nvSpPr>
+        <p:spPr>
+          <a:xfrm>
+            <a:off x="10012680" y="5468112"/>
+            <a:ext cx="960120" cy="274320"/>
+          </a:xfrm>
+          <a:prstGeom prst="rect">
+            <a:avLst/>
+          </a:prstGeom>
+          <a:noFill/>
+        </p:spPr>
+        <p:txBody>
+          <a:bodyPr wrap="square" anchor="t">
+            <a:spAutoFit/>
+          </a:bodyPr>
+          <a:lstStyle/>
+          <a:p>
+            <a:pPr algn="l">
+              <a:defRPr sz="900" b="0">
+                <a:solidFill>
+                  <a:srgbClr val="333333"/>
+                </a:solidFill>
+                <a:latin typeface="Calibri"/>
+              </a:defRPr>
+            </a:pPr>
+            <a:r>
+              <a:t>Troy SD</a:t>
+            </a:r>
+          </a:p>
+        </p:txBody>
+      </p:sp>
+      <p:sp>
+        <p:nvSpPr>
+          <p:cNvPr id="51" name="TextBox 50"/>
+          <p:cNvSpPr txBox="1"/>
+          <p:nvPr/>
+        </p:nvSpPr>
+        <p:spPr>
+          <a:xfrm>
+            <a:off x="10972800" y="5468112"/>
+            <a:ext cx="594360" cy="274320"/>
+          </a:xfrm>
+          <a:prstGeom prst="rect">
+            <a:avLst/>
+          </a:prstGeom>
+          <a:noFill/>
+        </p:spPr>
+        <p:txBody>
+          <a:bodyPr wrap="square" anchor="t">
+            <a:spAutoFit/>
+          </a:bodyPr>
+          <a:lstStyle/>
+          <a:p>
+            <a:pPr algn="l">
+              <a:defRPr sz="900" b="1">
+                <a:solidFill>
+                  <a:srgbClr val="B02121"/>
+                </a:solidFill>
+                <a:latin typeface="Calibri"/>
+              </a:defRPr>
+            </a:pPr>
+            <a:r>
+              <a:t>-0.162</a:t>
+            </a:r>
+          </a:p>
+        </p:txBody>
+      </p:sp>
+      <p:sp>
+        <p:nvSpPr>
+          <p:cNvPr id="52" name="TextBox 51"/>
+          <p:cNvSpPr txBox="1"/>
+          <p:nvPr/>
+        </p:nvSpPr>
+        <p:spPr>
+          <a:xfrm>
+            <a:off x="5212080" y="5788152"/>
+            <a:ext cx="960120" cy="274320"/>
+          </a:xfrm>
+          <a:prstGeom prst="rect">
+            <a:avLst/>
+          </a:prstGeom>
+          <a:noFill/>
+        </p:spPr>
+        <p:txBody>
+          <a:bodyPr wrap="square" anchor="t">
+            <a:spAutoFit/>
+          </a:bodyPr>
+          <a:lstStyle/>
+          <a:p>
+            <a:pPr algn="l">
+              <a:defRPr sz="900" b="0">
+                <a:solidFill>
+                  <a:srgbClr val="333333"/>
+                </a:solidFill>
+                <a:latin typeface="Calibri"/>
+              </a:defRPr>
+            </a:pPr>
+            <a:r>
+              <a:t>Novi</a:t>
+            </a:r>
+          </a:p>
+        </p:txBody>
+      </p:sp>
+      <p:sp>
+        <p:nvSpPr>
+          <p:cNvPr id="53" name="TextBox 52"/>
+          <p:cNvSpPr txBox="1"/>
+          <p:nvPr/>
+        </p:nvSpPr>
+        <p:spPr>
+          <a:xfrm>
+            <a:off x="6172200" y="5788152"/>
+            <a:ext cx="594360" cy="274320"/>
+          </a:xfrm>
+          <a:prstGeom prst="rect">
+            <a:avLst/>
+          </a:prstGeom>
+          <a:noFill/>
+        </p:spPr>
+        <p:txBody>
+          <a:bodyPr wrap="square" anchor="t">
+            <a:spAutoFit/>
+          </a:bodyPr>
+          <a:lstStyle/>
+          <a:p>
+            <a:pPr algn="l">
+              <a:defRPr sz="900" b="1">
+                <a:solidFill>
+                  <a:srgbClr val="B02121"/>
+                </a:solidFill>
+                <a:latin typeface="Calibri"/>
+              </a:defRPr>
+            </a:pPr>
+            <a:r>
+              <a:t>-0.167</a:t>
+            </a:r>
+          </a:p>
+        </p:txBody>
+      </p:sp>
+      <p:sp>
+        <p:nvSpPr>
+          <p:cNvPr id="54" name="TextBox 53"/>
+          <p:cNvSpPr txBox="1"/>
+          <p:nvPr/>
+        </p:nvSpPr>
+        <p:spPr>
+          <a:xfrm>
+            <a:off x="6812280" y="5788152"/>
+            <a:ext cx="960120" cy="274320"/>
+          </a:xfrm>
+          <a:prstGeom prst="rect">
+            <a:avLst/>
+          </a:prstGeom>
+          <a:noFill/>
+        </p:spPr>
+        <p:txBody>
+          <a:bodyPr wrap="square" anchor="t">
+            <a:spAutoFit/>
+          </a:bodyPr>
+          <a:lstStyle/>
+          <a:p>
+            <a:pPr algn="l">
+              <a:defRPr sz="900" b="0">
+                <a:solidFill>
+                  <a:srgbClr val="333333"/>
+                </a:solidFill>
+                <a:latin typeface="Calibri"/>
+              </a:defRPr>
+            </a:pPr>
+            <a:r>
+              <a:t>W. Bloomfield</a:t>
+            </a:r>
+          </a:p>
+        </p:txBody>
+      </p:sp>
+      <p:sp>
+        <p:nvSpPr>
+          <p:cNvPr id="55" name="TextBox 54"/>
+          <p:cNvSpPr txBox="1"/>
+          <p:nvPr/>
+        </p:nvSpPr>
+        <p:spPr>
+          <a:xfrm>
+            <a:off x="7772400" y="5788152"/>
+            <a:ext cx="594360" cy="274320"/>
+          </a:xfrm>
+          <a:prstGeom prst="rect">
+            <a:avLst/>
+          </a:prstGeom>
+          <a:noFill/>
+        </p:spPr>
+        <p:txBody>
+          <a:bodyPr wrap="square" anchor="t">
+            <a:spAutoFit/>
+          </a:bodyPr>
+          <a:lstStyle/>
+          <a:p>
+            <a:pPr algn="l">
+              <a:defRPr sz="900" b="1">
+                <a:solidFill>
+                  <a:srgbClr val="B02121"/>
+                </a:solidFill>
+                <a:latin typeface="Calibri"/>
+              </a:defRPr>
+            </a:pPr>
+            <a:r>
+              <a:t>-0.181</a:t>
+            </a:r>
+          </a:p>
+        </p:txBody>
+      </p:sp>
+      <p:sp>
+        <p:nvSpPr>
+          <p:cNvPr id="56" name="TextBox 55"/>
+          <p:cNvSpPr txBox="1"/>
+          <p:nvPr/>
+        </p:nvSpPr>
+        <p:spPr>
+          <a:xfrm>
+            <a:off x="8412480" y="5788152"/>
+            <a:ext cx="960120" cy="274320"/>
+          </a:xfrm>
+          <a:prstGeom prst="rect">
+            <a:avLst/>
+          </a:prstGeom>
+          <a:noFill/>
+        </p:spPr>
+        <p:txBody>
+          <a:bodyPr wrap="square" anchor="t">
+            <a:spAutoFit/>
+          </a:bodyPr>
+          <a:lstStyle/>
+          <a:p>
+            <a:pPr algn="l">
+              <a:defRPr sz="900" b="0">
+                <a:solidFill>
+                  <a:srgbClr val="333333"/>
+                </a:solidFill>
+                <a:latin typeface="Calibri"/>
+              </a:defRPr>
+            </a:pPr>
+            <a:r>
+              <a:t>Rochester</a:t>
+            </a:r>
+          </a:p>
+        </p:txBody>
+      </p:sp>
+      <p:sp>
+        <p:nvSpPr>
+          <p:cNvPr id="57" name="TextBox 56"/>
+          <p:cNvSpPr txBox="1"/>
+          <p:nvPr/>
+        </p:nvSpPr>
+        <p:spPr>
+          <a:xfrm>
+            <a:off x="9372600" y="5788152"/>
+            <a:ext cx="594360" cy="274320"/>
+          </a:xfrm>
+          <a:prstGeom prst="rect">
+            <a:avLst/>
+          </a:prstGeom>
+          <a:noFill/>
+        </p:spPr>
+        <p:txBody>
+          <a:bodyPr wrap="square" anchor="t">
+            <a:spAutoFit/>
+          </a:bodyPr>
+          <a:lstStyle/>
+          <a:p>
+            <a:pPr algn="l">
+              <a:defRPr sz="900" b="1">
+                <a:solidFill>
+                  <a:srgbClr val="B02121"/>
+                </a:solidFill>
+                <a:latin typeface="Calibri"/>
+              </a:defRPr>
+            </a:pPr>
+            <a:r>
+              <a:t>-0.188</a:t>
+            </a:r>
+          </a:p>
+        </p:txBody>
+      </p:sp>
+      <p:sp>
+        <p:nvSpPr>
+          <p:cNvPr id="58" name="TextBox 57"/>
+          <p:cNvSpPr txBox="1"/>
+          <p:nvPr/>
+        </p:nvSpPr>
+        <p:spPr>
+          <a:xfrm>
+            <a:off x="10012680" y="5788152"/>
+            <a:ext cx="960120" cy="274320"/>
+          </a:xfrm>
+          <a:prstGeom prst="rect">
+            <a:avLst/>
+          </a:prstGeom>
+          <a:noFill/>
+        </p:spPr>
+        <p:txBody>
+          <a:bodyPr wrap="square" anchor="t">
+            <a:spAutoFit/>
+          </a:bodyPr>
+          <a:lstStyle/>
+          <a:p>
+            <a:pPr algn="l">
+              <a:defRPr sz="900" b="0">
+                <a:solidFill>
+                  <a:srgbClr val="333333"/>
+                </a:solidFill>
+                <a:latin typeface="Calibri"/>
+              </a:defRPr>
+            </a:pPr>
+            <a:r>
+              <a:t>Walled Lake</a:t>
+            </a:r>
+          </a:p>
+        </p:txBody>
+      </p:sp>
+      <p:sp>
+        <p:nvSpPr>
+          <p:cNvPr id="59" name="TextBox 58"/>
+          <p:cNvSpPr txBox="1"/>
+          <p:nvPr/>
+        </p:nvSpPr>
+        <p:spPr>
+          <a:xfrm>
+            <a:off x="10972800" y="5788152"/>
+            <a:ext cx="594360" cy="274320"/>
+          </a:xfrm>
+          <a:prstGeom prst="rect">
+            <a:avLst/>
+          </a:prstGeom>
+          <a:noFill/>
+        </p:spPr>
+        <p:txBody>
+          <a:bodyPr wrap="square" anchor="t">
+            <a:spAutoFit/>
+          </a:bodyPr>
+          <a:lstStyle/>
+          <a:p>
+            <a:pPr algn="l">
+              <a:defRPr sz="900" b="1">
+                <a:solidFill>
+                  <a:srgbClr val="B02121"/>
+                </a:solidFill>
+                <a:latin typeface="Calibri"/>
+              </a:defRPr>
+            </a:pPr>
+            <a:r>
+              <a:t>-0.197</a:t>
             </a:r>
           </a:p>
         </p:txBody>
@@ -11960,7 +14121,7 @@
             <a:pPr algn="l">
               <a:defRPr sz="1200" b="0">
                 <a:solidFill>
-                  <a:srgbClr val="A0B4CC"/>
+                  <a:srgbClr val="CCDDEE"/>
                 </a:solidFill>
                 <a:latin typeface="Calibri"/>
               </a:defRPr>
@@ -12081,7 +14242,7 @@
               </a:defRPr>
             </a:pPr>
             <a:r>
-              <a:t>3 / 19</a:t>
+              <a:t>3 / 20</a:t>
             </a:r>
           </a:p>
         </p:txBody>
@@ -12144,7 +14305,7 @@
             <a:avLst/>
           </a:prstGeom>
           <a:solidFill>
-            <a:srgbClr val="C8302F"/>
+            <a:srgbClr val="B02121"/>
           </a:solidFill>
           <a:ln>
             <a:noFill/>
@@ -12263,7 +14424,7 @@
             <a:avLst/>
           </a:prstGeom>
           <a:solidFill>
-            <a:srgbClr val="B7791F"/>
+            <a:srgbClr val="CC6A11"/>
           </a:solidFill>
           <a:ln>
             <a:noFill/>
@@ -12382,7 +14543,7 @@
             <a:avLst/>
           </a:prstGeom>
           <a:solidFill>
-            <a:srgbClr val="B7791F"/>
+            <a:srgbClr val="CC6A11"/>
           </a:solidFill>
           <a:ln>
             <a:noFill/>
@@ -12620,7 +14781,7 @@
             <a:avLst/>
           </a:prstGeom>
           <a:solidFill>
-            <a:srgbClr val="F2F4F7"/>
+            <a:srgbClr val="EEEEEE"/>
           </a:solidFill>
           <a:ln>
             <a:noFill/>
@@ -12673,7 +14834,7 @@
             <a:pPr algn="l">
               <a:defRPr sz="1300" b="0">
                 <a:solidFill>
-                  <a:srgbClr val="777777"/>
+                  <a:srgbClr val="707070"/>
                 </a:solidFill>
                 <a:latin typeface="Calibri"/>
               </a:defRPr>
@@ -12814,7 +14975,7 @@
             <a:pPr algn="l">
               <a:defRPr sz="1200" b="0">
                 <a:solidFill>
-                  <a:srgbClr val="A0B4CC"/>
+                  <a:srgbClr val="CCDDEE"/>
                 </a:solidFill>
                 <a:latin typeface="Calibri"/>
               </a:defRPr>
@@ -12935,7 +15096,7 @@
               </a:defRPr>
             </a:pPr>
             <a:r>
-              <a:t>4 / 19</a:t>
+              <a:t>4 / 20</a:t>
             </a:r>
           </a:p>
         </p:txBody>
@@ -12979,7 +15140,7 @@
             <a:avLst/>
           </a:prstGeom>
           <a:solidFill>
-            <a:srgbClr val="E8F5EE"/>
+            <a:srgbClr val="E6F4E8"/>
           </a:solidFill>
           <a:ln>
             <a:noFill/>
@@ -13270,7 +15431,7 @@
             <a:pPr algn="l">
               <a:defRPr sz="1200" b="0">
                 <a:solidFill>
-                  <a:srgbClr val="A0B4CC"/>
+                  <a:srgbClr val="CCDDEE"/>
                 </a:solidFill>
                 <a:latin typeface="Calibri"/>
               </a:defRPr>
@@ -13391,7 +15552,7 @@
               </a:defRPr>
             </a:pPr>
             <a:r>
-              <a:t>5 / 19</a:t>
+              <a:t>5 / 20</a:t>
             </a:r>
           </a:p>
         </p:txBody>
@@ -13435,7 +15596,7 @@
             <a:avLst/>
           </a:prstGeom>
           <a:solidFill>
-            <a:srgbClr val="FBE7E6"/>
+            <a:srgbClr val="FCE4E4"/>
           </a:solidFill>
           <a:ln>
             <a:noFill/>
@@ -13488,7 +15649,7 @@
             <a:pPr algn="l">
               <a:defRPr sz="3000" b="1">
                 <a:solidFill>
-                  <a:srgbClr val="C8302F"/>
+                  <a:srgbClr val="B02121"/>
                 </a:solidFill>
                 <a:latin typeface="Calibri"/>
               </a:defRPr>
@@ -13742,7 +15903,7 @@
             <a:pPr algn="l">
               <a:defRPr sz="1200" b="0">
                 <a:solidFill>
-                  <a:srgbClr val="A0B4CC"/>
+                  <a:srgbClr val="CCDDEE"/>
                 </a:solidFill>
                 <a:latin typeface="Calibri"/>
               </a:defRPr>
@@ -13863,7 +16024,7 @@
               </a:defRPr>
             </a:pPr>
             <a:r>
-              <a:t>6 / 19</a:t>
+              <a:t>6 / 20</a:t>
             </a:r>
           </a:p>
         </p:txBody>
@@ -13907,7 +16068,7 @@
             <a:avLst/>
           </a:prstGeom>
           <a:solidFill>
-            <a:srgbClr val="FBE7E6"/>
+            <a:srgbClr val="FCE4E4"/>
           </a:solidFill>
           <a:ln>
             <a:noFill/>
@@ -14262,7 +16423,7 @@
             <a:pPr algn="ctr">
               <a:defRPr sz="1300" b="1">
                 <a:solidFill>
-                  <a:srgbClr val="777777"/>
+                  <a:srgbClr val="707070"/>
                 </a:solidFill>
                 <a:latin typeface="Calibri"/>
               </a:defRPr>
@@ -14288,7 +16449,7 @@
             <a:avLst/>
           </a:prstGeom>
           <a:solidFill>
-            <a:srgbClr val="F2F4F7"/>
+            <a:srgbClr val="EEEEEE"/>
           </a:solidFill>
           <a:ln>
             <a:noFill/>
@@ -14413,7 +16574,7 @@
             <a:pPr algn="ctr">
               <a:defRPr sz="1300" b="1">
                 <a:solidFill>
-                  <a:srgbClr val="777777"/>
+                  <a:srgbClr val="707070"/>
                 </a:solidFill>
                 <a:latin typeface="Calibri"/>
               </a:defRPr>
@@ -14564,7 +16725,7 @@
             <a:pPr algn="ctr">
               <a:defRPr sz="1300" b="1">
                 <a:solidFill>
-                  <a:srgbClr val="C8302F"/>
+                  <a:srgbClr val="B02121"/>
                 </a:solidFill>
                 <a:latin typeface="Calibri"/>
               </a:defRPr>
@@ -14590,7 +16751,7 @@
             <a:avLst/>
           </a:prstGeom>
           <a:solidFill>
-            <a:srgbClr val="F2F4F7"/>
+            <a:srgbClr val="EEEEEE"/>
           </a:solidFill>
           <a:ln>
             <a:noFill/>
@@ -14715,7 +16876,7 @@
             <a:pPr algn="ctr">
               <a:defRPr sz="1300" b="1">
                 <a:solidFill>
-                  <a:srgbClr val="777777"/>
+                  <a:srgbClr val="707070"/>
                 </a:solidFill>
                 <a:latin typeface="Calibri"/>
               </a:defRPr>
@@ -14866,7 +17027,7 @@
             <a:pPr algn="ctr">
               <a:defRPr sz="1300" b="1">
                 <a:solidFill>
-                  <a:srgbClr val="777777"/>
+                  <a:srgbClr val="707070"/>
                 </a:solidFill>
                 <a:latin typeface="Calibri"/>
               </a:defRPr>
@@ -14902,7 +17063,7 @@
             <a:pPr algn="l">
               <a:defRPr sz="1200" b="1">
                 <a:solidFill>
-                  <a:srgbClr val="B7791F"/>
+                  <a:srgbClr val="CC6A11"/>
                 </a:solidFill>
                 <a:latin typeface="Calibri"/>
               </a:defRPr>
@@ -15047,7 +17208,7 @@
             <a:pPr algn="l">
               <a:defRPr sz="1200" b="0">
                 <a:solidFill>
-                  <a:srgbClr val="A0B4CC"/>
+                  <a:srgbClr val="CCDDEE"/>
                 </a:solidFill>
                 <a:latin typeface="Calibri"/>
               </a:defRPr>
@@ -15168,7 +17329,7 @@
               </a:defRPr>
             </a:pPr>
             <a:r>
-              <a:t>7 / 19</a:t>
+              <a:t>7 / 20</a:t>
             </a:r>
           </a:p>
         </p:txBody>
@@ -15265,7 +17426,7 @@
             <a:pPr algn="l">
               <a:defRPr sz="3200" b="1">
                 <a:solidFill>
-                  <a:srgbClr val="B7791F"/>
+                  <a:srgbClr val="CC6A11"/>
                 </a:solidFill>
                 <a:latin typeface="Calibri"/>
               </a:defRPr>
@@ -15535,7 +17696,7 @@
             <a:pPr algn="l">
               <a:defRPr sz="1200" b="0">
                 <a:solidFill>
-                  <a:srgbClr val="A0B4CC"/>
+                  <a:srgbClr val="CCDDEE"/>
                 </a:solidFill>
                 <a:latin typeface="Calibri"/>
               </a:defRPr>
@@ -15656,7 +17817,7 @@
               </a:defRPr>
             </a:pPr>
             <a:r>
-              <a:t>8 / 19</a:t>
+              <a:t>8 / 20</a:t>
             </a:r>
           </a:p>
         </p:txBody>
@@ -15700,7 +17861,7 @@
             <a:avLst/>
           </a:prstGeom>
           <a:solidFill>
-            <a:srgbClr val="FBE7E6"/>
+            <a:srgbClr val="FCE4E4"/>
           </a:solidFill>
           <a:ln>
             <a:noFill/>
@@ -15753,7 +17914,7 @@
             <a:pPr algn="l">
               <a:defRPr sz="2800" b="1">
                 <a:solidFill>
-                  <a:srgbClr val="C8302F"/>
+                  <a:srgbClr val="B02121"/>
                 </a:solidFill>
                 <a:latin typeface="Calibri"/>
               </a:defRPr>
@@ -15789,7 +17950,7 @@
             <a:pPr algn="l">
               <a:defRPr sz="1800" b="1">
                 <a:solidFill>
-                  <a:srgbClr val="C8302F"/>
+                  <a:srgbClr val="B02121"/>
                 </a:solidFill>
                 <a:latin typeface="Calibri"/>
               </a:defRPr>
@@ -16014,7 +18175,7 @@
             <a:pPr algn="l">
               <a:defRPr sz="1200" b="0">
                 <a:solidFill>
-                  <a:srgbClr val="A0B4CC"/>
+                  <a:srgbClr val="CCDDEE"/>
                 </a:solidFill>
                 <a:latin typeface="Calibri"/>
               </a:defRPr>
@@ -16135,7 +18296,7 @@
               </a:defRPr>
             </a:pPr>
             <a:r>
-              <a:t>9 / 19</a:t>
+              <a:t>9 / 20</a:t>
             </a:r>
           </a:p>
         </p:txBody>
@@ -16179,7 +18340,7 @@
             <a:avLst/>
           </a:prstGeom>
           <a:solidFill>
-            <a:srgbClr val="F2F4F7"/>
+            <a:srgbClr val="EEEEEE"/>
           </a:solidFill>
           <a:ln>
             <a:noFill/>
@@ -16412,7 +18573,7 @@
             <a:pPr algn="l">
               <a:defRPr sz="1100" b="0">
                 <a:solidFill>
-                  <a:srgbClr val="777777"/>
+                  <a:srgbClr val="707070"/>
                 </a:solidFill>
                 <a:latin typeface="Calibri"/>
               </a:defRPr>
@@ -16520,7 +18681,7 @@
             <a:pPr algn="l">
               <a:defRPr sz="1100" b="0">
                 <a:solidFill>
-                  <a:srgbClr val="777777"/>
+                  <a:srgbClr val="707070"/>
                 </a:solidFill>
                 <a:latin typeface="Calibri"/>
               </a:defRPr>
@@ -16700,7 +18861,7 @@
             <a:pPr algn="l">
               <a:defRPr sz="1100" b="0">
                 <a:solidFill>
-                  <a:srgbClr val="777777"/>
+                  <a:srgbClr val="707070"/>
                 </a:solidFill>
                 <a:latin typeface="Calibri"/>
               </a:defRPr>
@@ -16726,7 +18887,7 @@
             <a:avLst/>
           </a:prstGeom>
           <a:solidFill>
-            <a:srgbClr val="FBE7E6"/>
+            <a:srgbClr val="FCE4E4"/>
           </a:solidFill>
           <a:ln>
             <a:noFill/>
@@ -16779,7 +18940,7 @@
             <a:pPr algn="l">
               <a:defRPr sz="1300" b="1">
                 <a:solidFill>
-                  <a:srgbClr val="C8302F"/>
+                  <a:srgbClr val="B02121"/>
                 </a:solidFill>
                 <a:latin typeface="Calibri"/>
               </a:defRPr>
@@ -16815,7 +18976,7 @@
             <a:pPr algn="l">
               <a:defRPr sz="1300" b="1">
                 <a:solidFill>
-                  <a:srgbClr val="C8302F"/>
+                  <a:srgbClr val="B02121"/>
                 </a:solidFill>
                 <a:latin typeface="Calibri"/>
               </a:defRPr>
@@ -16851,7 +19012,7 @@
             <a:pPr algn="l">
               <a:defRPr sz="1100" b="0">
                 <a:solidFill>
-                  <a:srgbClr val="777777"/>
+                  <a:srgbClr val="707070"/>
                 </a:solidFill>
                 <a:latin typeface="Calibri"/>
               </a:defRPr>

</xml_diff>